<commit_message>
live edtis and minor chunk edits
</commit_message>
<xml_diff>
--- a/Lecture Resources/Lecture Powerpoints/Chunk 12 - Scipy and Linear Regressions.pptx
+++ b/Lecture Resources/Lecture Powerpoints/Chunk 12 - Scipy and Linear Regressions.pptx
@@ -5,12 +5,15 @@
     <p:sldMasterId id="2147483648" r:id="rId1"/>
   </p:sldMasterIdLst>
   <p:notesMasterIdLst>
-    <p:notesMasterId r:id="rId5"/>
+    <p:notesMasterId r:id="rId8"/>
   </p:notesMasterIdLst>
   <p:sldIdLst>
     <p:sldId id="256" r:id="rId2"/>
-    <p:sldId id="269" r:id="rId3"/>
-    <p:sldId id="267" r:id="rId4"/>
+    <p:sldId id="271" r:id="rId3"/>
+    <p:sldId id="270" r:id="rId4"/>
+    <p:sldId id="272" r:id="rId5"/>
+    <p:sldId id="269" r:id="rId6"/>
+    <p:sldId id="267" r:id="rId7"/>
   </p:sldIdLst>
   <p:sldSz cx="12192000" cy="6858000"/>
   <p:notesSz cx="6858000" cy="9144000"/>
@@ -120,7 +123,7 @@
 <file path=ppt/revisionInfo.xml><?xml version="1.0" encoding="utf-8"?>
 <p1510:revInfo xmlns:a="http://schemas.openxmlformats.org/drawingml/2006/main" xmlns:r="http://schemas.openxmlformats.org/officeDocument/2006/relationships" xmlns:p1510="http://schemas.microsoft.com/office/powerpoint/2015/10/main">
   <p1510:revLst>
-    <p1510:client id="{256A9018-AECF-4963-8EC0-2214957FAF86}" v="1" dt="2025-10-04T21:37:04.844"/>
+    <p1510:client id="{26B21A4E-A3B0-4BFF-AA89-EF6C9284D602}" v="2" dt="2025-10-09T08:45:15.085"/>
   </p1510:revLst>
 </p1510:revInfo>
 </file>
@@ -215,19 +218,19 @@
   </pc:docChgLst>
   <pc:docChgLst>
     <pc:chgData name="Jonathan Bollig" userId="8b5d0afe-f106-45e0-8c3f-fd98fa124db1" providerId="ADAL" clId="{B2469FA9-EBD8-4834-A16D-CBF8EFC907DD}"/>
-    <pc:docChg chg="custSel addSld delSld modSld">
-      <pc:chgData name="Jonathan Bollig" userId="8b5d0afe-f106-45e0-8c3f-fd98fa124db1" providerId="ADAL" clId="{B2469FA9-EBD8-4834-A16D-CBF8EFC907DD}" dt="2025-10-04T21:37:04.844" v="18"/>
+    <pc:docChg chg="undo custSel addSld delSld modSld">
+      <pc:chgData name="Jonathan Bollig" userId="8b5d0afe-f106-45e0-8c3f-fd98fa124db1" providerId="ADAL" clId="{B2469FA9-EBD8-4834-A16D-CBF8EFC907DD}" dt="2025-10-09T08:49:10.323" v="276" actId="1440"/>
       <pc:docMkLst>
         <pc:docMk/>
       </pc:docMkLst>
       <pc:sldChg chg="modSp mod">
-        <pc:chgData name="Jonathan Bollig" userId="8b5d0afe-f106-45e0-8c3f-fd98fa124db1" providerId="ADAL" clId="{B2469FA9-EBD8-4834-A16D-CBF8EFC907DD}" dt="2025-09-30T13:24:16.541" v="12" actId="6549"/>
+        <pc:chgData name="Jonathan Bollig" userId="8b5d0afe-f106-45e0-8c3f-fd98fa124db1" providerId="ADAL" clId="{B2469FA9-EBD8-4834-A16D-CBF8EFC907DD}" dt="2025-10-08T16:48:27.446" v="71" actId="20577"/>
         <pc:sldMkLst>
           <pc:docMk/>
           <pc:sldMk cId="836289018" sldId="256"/>
         </pc:sldMkLst>
         <pc:spChg chg="mod">
-          <ac:chgData name="Jonathan Bollig" userId="8b5d0afe-f106-45e0-8c3f-fd98fa124db1" providerId="ADAL" clId="{B2469FA9-EBD8-4834-A16D-CBF8EFC907DD}" dt="2025-09-30T13:24:16.541" v="12" actId="6549"/>
+          <ac:chgData name="Jonathan Bollig" userId="8b5d0afe-f106-45e0-8c3f-fd98fa124db1" providerId="ADAL" clId="{B2469FA9-EBD8-4834-A16D-CBF8EFC907DD}" dt="2025-10-08T16:48:27.446" v="71" actId="20577"/>
           <ac:spMkLst>
             <pc:docMk/>
             <pc:sldMk cId="836289018" sldId="256"/>
@@ -275,6 +278,83 @@
             <pc:docMk/>
             <pc:sldMk cId="2113368255" sldId="269"/>
             <ac:spMk id="3" creationId="{90A723FE-AE4A-BC31-F8DA-B479D4E846FF}"/>
+          </ac:spMkLst>
+        </pc:spChg>
+      </pc:sldChg>
+      <pc:sldChg chg="addSp modSp new mod">
+        <pc:chgData name="Jonathan Bollig" userId="8b5d0afe-f106-45e0-8c3f-fd98fa124db1" providerId="ADAL" clId="{B2469FA9-EBD8-4834-A16D-CBF8EFC907DD}" dt="2025-10-09T08:49:10.323" v="276" actId="1440"/>
+        <pc:sldMkLst>
+          <pc:docMk/>
+          <pc:sldMk cId="1924031238" sldId="270"/>
+        </pc:sldMkLst>
+        <pc:spChg chg="mod">
+          <ac:chgData name="Jonathan Bollig" userId="8b5d0afe-f106-45e0-8c3f-fd98fa124db1" providerId="ADAL" clId="{B2469FA9-EBD8-4834-A16D-CBF8EFC907DD}" dt="2025-10-09T08:36:58.593" v="111" actId="20577"/>
+          <ac:spMkLst>
+            <pc:docMk/>
+            <pc:sldMk cId="1924031238" sldId="270"/>
+            <ac:spMk id="2" creationId="{339CC981-66B0-B525-990A-B908AEE5C0E5}"/>
+          </ac:spMkLst>
+        </pc:spChg>
+        <pc:spChg chg="mod">
+          <ac:chgData name="Jonathan Bollig" userId="8b5d0afe-f106-45e0-8c3f-fd98fa124db1" providerId="ADAL" clId="{B2469FA9-EBD8-4834-A16D-CBF8EFC907DD}" dt="2025-10-09T08:37:58.015" v="142" actId="20577"/>
+          <ac:spMkLst>
+            <pc:docMk/>
+            <pc:sldMk cId="1924031238" sldId="270"/>
+            <ac:spMk id="3" creationId="{F7398BD2-D422-25F5-BFB0-DD9B594C0435}"/>
+          </ac:spMkLst>
+        </pc:spChg>
+        <pc:picChg chg="add mod">
+          <ac:chgData name="Jonathan Bollig" userId="8b5d0afe-f106-45e0-8c3f-fd98fa124db1" providerId="ADAL" clId="{B2469FA9-EBD8-4834-A16D-CBF8EFC907DD}" dt="2025-10-09T08:49:10.323" v="276" actId="1440"/>
+          <ac:picMkLst>
+            <pc:docMk/>
+            <pc:sldMk cId="1924031238" sldId="270"/>
+            <ac:picMk id="5" creationId="{C101CA24-C238-50B0-DCE2-7D2134797418}"/>
+          </ac:picMkLst>
+        </pc:picChg>
+      </pc:sldChg>
+      <pc:sldChg chg="addSp modSp new mod">
+        <pc:chgData name="Jonathan Bollig" userId="8b5d0afe-f106-45e0-8c3f-fd98fa124db1" providerId="ADAL" clId="{B2469FA9-EBD8-4834-A16D-CBF8EFC907DD}" dt="2025-10-09T08:45:16.181" v="272" actId="20577"/>
+        <pc:sldMkLst>
+          <pc:docMk/>
+          <pc:sldMk cId="2101106813" sldId="271"/>
+        </pc:sldMkLst>
+        <pc:spChg chg="mod">
+          <ac:chgData name="Jonathan Bollig" userId="8b5d0afe-f106-45e0-8c3f-fd98fa124db1" providerId="ADAL" clId="{B2469FA9-EBD8-4834-A16D-CBF8EFC907DD}" dt="2025-10-09T08:40:42.463" v="167" actId="20577"/>
+          <ac:spMkLst>
+            <pc:docMk/>
+            <pc:sldMk cId="2101106813" sldId="271"/>
+            <ac:spMk id="2" creationId="{C35F9678-53F9-7225-22B7-BB8411794FF0}"/>
+          </ac:spMkLst>
+        </pc:spChg>
+        <pc:spChg chg="mod">
+          <ac:chgData name="Jonathan Bollig" userId="8b5d0afe-f106-45e0-8c3f-fd98fa124db1" providerId="ADAL" clId="{B2469FA9-EBD8-4834-A16D-CBF8EFC907DD}" dt="2025-10-09T08:45:16.181" v="272" actId="20577"/>
+          <ac:spMkLst>
+            <pc:docMk/>
+            <pc:sldMk cId="2101106813" sldId="271"/>
+            <ac:spMk id="3" creationId="{F2A54FCC-D5D9-3B2A-A578-49C5C69BD26F}"/>
+          </ac:spMkLst>
+        </pc:spChg>
+        <pc:picChg chg="add mod">
+          <ac:chgData name="Jonathan Bollig" userId="8b5d0afe-f106-45e0-8c3f-fd98fa124db1" providerId="ADAL" clId="{B2469FA9-EBD8-4834-A16D-CBF8EFC907DD}" dt="2025-10-09T08:43:41.297" v="236" actId="1076"/>
+          <ac:picMkLst>
+            <pc:docMk/>
+            <pc:sldMk cId="2101106813" sldId="271"/>
+            <ac:picMk id="5" creationId="{0D7DA34C-2279-C293-581F-2768BA9B9C7D}"/>
+          </ac:picMkLst>
+        </pc:picChg>
+      </pc:sldChg>
+      <pc:sldChg chg="modSp new mod">
+        <pc:chgData name="Jonathan Bollig" userId="8b5d0afe-f106-45e0-8c3f-fd98fa124db1" providerId="ADAL" clId="{B2469FA9-EBD8-4834-A16D-CBF8EFC907DD}" dt="2025-10-09T08:40:54.918" v="173" actId="20577"/>
+        <pc:sldMkLst>
+          <pc:docMk/>
+          <pc:sldMk cId="876603943" sldId="272"/>
+        </pc:sldMkLst>
+        <pc:spChg chg="mod">
+          <ac:chgData name="Jonathan Bollig" userId="8b5d0afe-f106-45e0-8c3f-fd98fa124db1" providerId="ADAL" clId="{B2469FA9-EBD8-4834-A16D-CBF8EFC907DD}" dt="2025-10-09T08:40:54.918" v="173" actId="20577"/>
+          <ac:spMkLst>
+            <pc:docMk/>
+            <pc:sldMk cId="876603943" sldId="272"/>
+            <ac:spMk id="2" creationId="{71537927-8CAF-B909-7E79-56BB2B379D9C}"/>
           </ac:spMkLst>
         </pc:spChg>
       </pc:sldChg>
@@ -512,7 +592,7 @@
           <a:p>
             <a:fld id="{0B6CA2EE-5589-4682-AD7F-744DBF1E81F5}" type="datetimeFigureOut">
               <a:rPr lang="de-DE" smtClean="0"/>
-              <a:t>04.10.2025</a:t>
+              <a:t>08.10.2025</a:t>
             </a:fld>
             <a:endParaRPr lang="de-DE"/>
           </a:p>
@@ -926,7 +1006,7 @@
           <a:p>
             <a:fld id="{ADA51F25-4808-47F4-BF6E-BCDC230DB01C}" type="datetimeFigureOut">
               <a:rPr lang="de-DE" smtClean="0"/>
-              <a:t>04.10.2025</a:t>
+              <a:t>08.10.2025</a:t>
             </a:fld>
             <a:endParaRPr lang="de-DE"/>
           </a:p>
@@ -1124,7 +1204,7 @@
           <a:p>
             <a:fld id="{ADA51F25-4808-47F4-BF6E-BCDC230DB01C}" type="datetimeFigureOut">
               <a:rPr lang="de-DE" smtClean="0"/>
-              <a:t>04.10.2025</a:t>
+              <a:t>08.10.2025</a:t>
             </a:fld>
             <a:endParaRPr lang="de-DE"/>
           </a:p>
@@ -1332,7 +1412,7 @@
           <a:p>
             <a:fld id="{ADA51F25-4808-47F4-BF6E-BCDC230DB01C}" type="datetimeFigureOut">
               <a:rPr lang="de-DE" smtClean="0"/>
-              <a:t>04.10.2025</a:t>
+              <a:t>08.10.2025</a:t>
             </a:fld>
             <a:endParaRPr lang="de-DE"/>
           </a:p>
@@ -1530,7 +1610,7 @@
           <a:p>
             <a:fld id="{ADA51F25-4808-47F4-BF6E-BCDC230DB01C}" type="datetimeFigureOut">
               <a:rPr lang="de-DE" smtClean="0"/>
-              <a:t>04.10.2025</a:t>
+              <a:t>08.10.2025</a:t>
             </a:fld>
             <a:endParaRPr lang="de-DE"/>
           </a:p>
@@ -1805,7 +1885,7 @@
           <a:p>
             <a:fld id="{ADA51F25-4808-47F4-BF6E-BCDC230DB01C}" type="datetimeFigureOut">
               <a:rPr lang="de-DE" smtClean="0"/>
-              <a:t>04.10.2025</a:t>
+              <a:t>08.10.2025</a:t>
             </a:fld>
             <a:endParaRPr lang="de-DE"/>
           </a:p>
@@ -2070,7 +2150,7 @@
           <a:p>
             <a:fld id="{ADA51F25-4808-47F4-BF6E-BCDC230DB01C}" type="datetimeFigureOut">
               <a:rPr lang="de-DE" smtClean="0"/>
-              <a:t>04.10.2025</a:t>
+              <a:t>08.10.2025</a:t>
             </a:fld>
             <a:endParaRPr lang="de-DE"/>
           </a:p>
@@ -2482,7 +2562,7 @@
           <a:p>
             <a:fld id="{ADA51F25-4808-47F4-BF6E-BCDC230DB01C}" type="datetimeFigureOut">
               <a:rPr lang="de-DE" smtClean="0"/>
-              <a:t>04.10.2025</a:t>
+              <a:t>08.10.2025</a:t>
             </a:fld>
             <a:endParaRPr lang="de-DE"/>
           </a:p>
@@ -2623,7 +2703,7 @@
           <a:p>
             <a:fld id="{ADA51F25-4808-47F4-BF6E-BCDC230DB01C}" type="datetimeFigureOut">
               <a:rPr lang="de-DE" smtClean="0"/>
-              <a:t>04.10.2025</a:t>
+              <a:t>08.10.2025</a:t>
             </a:fld>
             <a:endParaRPr lang="de-DE"/>
           </a:p>
@@ -2736,7 +2816,7 @@
           <a:p>
             <a:fld id="{ADA51F25-4808-47F4-BF6E-BCDC230DB01C}" type="datetimeFigureOut">
               <a:rPr lang="de-DE" smtClean="0"/>
-              <a:t>04.10.2025</a:t>
+              <a:t>08.10.2025</a:t>
             </a:fld>
             <a:endParaRPr lang="de-DE"/>
           </a:p>
@@ -3047,7 +3127,7 @@
           <a:p>
             <a:fld id="{ADA51F25-4808-47F4-BF6E-BCDC230DB01C}" type="datetimeFigureOut">
               <a:rPr lang="de-DE" smtClean="0"/>
-              <a:t>04.10.2025</a:t>
+              <a:t>08.10.2025</a:t>
             </a:fld>
             <a:endParaRPr lang="de-DE"/>
           </a:p>
@@ -3335,7 +3415,7 @@
           <a:p>
             <a:fld id="{ADA51F25-4808-47F4-BF6E-BCDC230DB01C}" type="datetimeFigureOut">
               <a:rPr lang="de-DE" smtClean="0"/>
-              <a:t>04.10.2025</a:t>
+              <a:t>08.10.2025</a:t>
             </a:fld>
             <a:endParaRPr lang="de-DE"/>
           </a:p>
@@ -3576,7 +3656,7 @@
           <a:p>
             <a:fld id="{ADA51F25-4808-47F4-BF6E-BCDC230DB01C}" type="datetimeFigureOut">
               <a:rPr lang="de-DE" smtClean="0"/>
-              <a:t>04.10.2025</a:t>
+              <a:t>08.10.2025</a:t>
             </a:fld>
             <a:endParaRPr lang="de-DE"/>
           </a:p>
@@ -4028,15 +4108,19 @@
               <a:t>(And everyone else!)</a:t>
             </a:r>
             <a:br>
-              <a:rPr lang="en-US" noProof="0"/>
+              <a:rPr lang="en-US" noProof="0" dirty="0"/>
             </a:br>
             <a:r>
-              <a:rPr lang="en-US" noProof="0"/>
-              <a:t>Chunk </a:t>
-            </a:r>
-            <a:r>
               <a:rPr lang="en-US" noProof="0" dirty="0"/>
-              <a:t>X: Blank</a:t>
+              <a:t>Chunk 12: </a:t>
+            </a:r>
+            <a:r>
+              <a:rPr lang="en-US" noProof="0" dirty="0" err="1"/>
+              <a:t>Scipy</a:t>
+            </a:r>
+            <a:r>
+              <a:rPr lang="en-US" noProof="0" dirty="0"/>
+              <a:t> &amp; Regressions</a:t>
             </a:r>
           </a:p>
         </p:txBody>
@@ -4089,6 +4173,399 @@
 </file>
 
 <file path=ppt/slides/slide2.xml><?xml version="1.0" encoding="utf-8"?>
+<p:sld xmlns:a="http://schemas.openxmlformats.org/drawingml/2006/main" xmlns:r="http://schemas.openxmlformats.org/officeDocument/2006/relationships" xmlns:p="http://schemas.openxmlformats.org/presentationml/2006/main">
+  <p:cSld>
+    <p:spTree>
+      <p:nvGrpSpPr>
+        <p:cNvPr id="1" name=""/>
+        <p:cNvGrpSpPr/>
+        <p:nvPr/>
+      </p:nvGrpSpPr>
+      <p:grpSpPr>
+        <a:xfrm>
+          <a:off x="0" y="0"/>
+          <a:ext cx="0" cy="0"/>
+          <a:chOff x="0" y="0"/>
+          <a:chExt cx="0" cy="0"/>
+        </a:xfrm>
+      </p:grpSpPr>
+      <p:sp>
+        <p:nvSpPr>
+          <p:cNvPr id="2" name="Titel 1">
+            <a:extLst>
+              <a:ext uri="{FF2B5EF4-FFF2-40B4-BE49-F238E27FC236}">
+                <a16:creationId xmlns:a16="http://schemas.microsoft.com/office/drawing/2014/main" id="{C35F9678-53F9-7225-22B7-BB8411794FF0}"/>
+              </a:ext>
+            </a:extLst>
+          </p:cNvPr>
+          <p:cNvSpPr>
+            <a:spLocks noGrp="1"/>
+          </p:cNvSpPr>
+          <p:nvPr>
+            <p:ph type="title"/>
+          </p:nvPr>
+        </p:nvSpPr>
+        <p:spPr/>
+        <p:txBody>
+          <a:bodyPr/>
+          <a:lstStyle/>
+          <a:p>
+            <a:r>
+              <a:rPr lang="en-US" dirty="0"/>
+              <a:t>Matplotlib: </a:t>
+            </a:r>
+            <a:r>
+              <a:rPr lang="en-US" dirty="0" err="1"/>
+              <a:t>rcParams</a:t>
+            </a:r>
+            <a:endParaRPr lang="en-US" dirty="0"/>
+          </a:p>
+        </p:txBody>
+      </p:sp>
+      <p:sp>
+        <p:nvSpPr>
+          <p:cNvPr id="3" name="Inhaltsplatzhalter 2">
+            <a:extLst>
+              <a:ext uri="{FF2B5EF4-FFF2-40B4-BE49-F238E27FC236}">
+                <a16:creationId xmlns:a16="http://schemas.microsoft.com/office/drawing/2014/main" id="{F2A54FCC-D5D9-3B2A-A578-49C5C69BD26F}"/>
+              </a:ext>
+            </a:extLst>
+          </p:cNvPr>
+          <p:cNvSpPr>
+            <a:spLocks noGrp="1"/>
+          </p:cNvSpPr>
+          <p:nvPr>
+            <p:ph idx="1"/>
+          </p:nvPr>
+        </p:nvSpPr>
+        <p:spPr/>
+        <p:txBody>
+          <a:bodyPr/>
+          <a:lstStyle/>
+          <a:p>
+            <a:r>
+              <a:rPr lang="en-US" dirty="0" err="1"/>
+              <a:t>rcParams</a:t>
+            </a:r>
+            <a:r>
+              <a:rPr lang="en-US" dirty="0"/>
+              <a:t>: Set style of plots for complete document:</a:t>
+            </a:r>
+          </a:p>
+          <a:p>
+            <a:endParaRPr lang="en-US" dirty="0"/>
+          </a:p>
+          <a:p>
+            <a:endParaRPr lang="en-US" dirty="0"/>
+          </a:p>
+          <a:p>
+            <a:endParaRPr lang="en-US" dirty="0"/>
+          </a:p>
+          <a:p>
+            <a:endParaRPr lang="en-US" dirty="0"/>
+          </a:p>
+          <a:p>
+            <a:endParaRPr lang="en-US" dirty="0"/>
+          </a:p>
+          <a:p>
+            <a:r>
+              <a:rPr lang="en-US" dirty="0"/>
+              <a:t>Complete set of parameters </a:t>
+            </a:r>
+            <a:r>
+              <a:rPr lang="en-US" dirty="0">
+                <a:hlinkClick r:id="rId2"/>
+              </a:rPr>
+              <a:t>here</a:t>
+            </a:r>
+            <a:r>
+              <a:rPr lang="en-US" dirty="0"/>
+              <a:t>.</a:t>
+            </a:r>
+          </a:p>
+        </p:txBody>
+      </p:sp>
+      <p:pic>
+        <p:nvPicPr>
+          <p:cNvPr id="5" name="Grafik 4">
+            <a:extLst>
+              <a:ext uri="{FF2B5EF4-FFF2-40B4-BE49-F238E27FC236}">
+                <a16:creationId xmlns:a16="http://schemas.microsoft.com/office/drawing/2014/main" id="{0D7DA34C-2279-C293-581F-2768BA9B9C7D}"/>
+              </a:ext>
+            </a:extLst>
+          </p:cNvPr>
+          <p:cNvPicPr>
+            <a:picLocks noChangeAspect="1"/>
+          </p:cNvPicPr>
+          <p:nvPr/>
+        </p:nvPicPr>
+        <p:blipFill>
+          <a:blip r:embed="rId3"/>
+          <a:stretch>
+            <a:fillRect/>
+          </a:stretch>
+        </p:blipFill>
+        <p:spPr>
+          <a:xfrm>
+            <a:off x="2480623" y="2594532"/>
+            <a:ext cx="6679423" cy="1816694"/>
+          </a:xfrm>
+          <a:prstGeom prst="rect">
+            <a:avLst/>
+          </a:prstGeom>
+        </p:spPr>
+      </p:pic>
+    </p:spTree>
+    <p:extLst>
+      <p:ext uri="{BB962C8B-B14F-4D97-AF65-F5344CB8AC3E}">
+        <p14:creationId xmlns:p14="http://schemas.microsoft.com/office/powerpoint/2010/main" val="2101106813"/>
+      </p:ext>
+    </p:extLst>
+  </p:cSld>
+  <p:clrMapOvr>
+    <a:masterClrMapping/>
+  </p:clrMapOvr>
+</p:sld>
+</file>
+
+<file path=ppt/slides/slide3.xml><?xml version="1.0" encoding="utf-8"?>
+<p:sld xmlns:a="http://schemas.openxmlformats.org/drawingml/2006/main" xmlns:r="http://schemas.openxmlformats.org/officeDocument/2006/relationships" xmlns:p="http://schemas.openxmlformats.org/presentationml/2006/main">
+  <p:cSld>
+    <p:spTree>
+      <p:nvGrpSpPr>
+        <p:cNvPr id="1" name=""/>
+        <p:cNvGrpSpPr/>
+        <p:nvPr/>
+      </p:nvGrpSpPr>
+      <p:grpSpPr>
+        <a:xfrm>
+          <a:off x="0" y="0"/>
+          <a:ext cx="0" cy="0"/>
+          <a:chOff x="0" y="0"/>
+          <a:chExt cx="0" cy="0"/>
+        </a:xfrm>
+      </p:grpSpPr>
+      <p:sp>
+        <p:nvSpPr>
+          <p:cNvPr id="2" name="Titel 1">
+            <a:extLst>
+              <a:ext uri="{FF2B5EF4-FFF2-40B4-BE49-F238E27FC236}">
+                <a16:creationId xmlns:a16="http://schemas.microsoft.com/office/drawing/2014/main" id="{339CC981-66B0-B525-990A-B908AEE5C0E5}"/>
+              </a:ext>
+            </a:extLst>
+          </p:cNvPr>
+          <p:cNvSpPr>
+            <a:spLocks noGrp="1"/>
+          </p:cNvSpPr>
+          <p:nvPr>
+            <p:ph type="title"/>
+          </p:nvPr>
+        </p:nvSpPr>
+        <p:spPr/>
+        <p:txBody>
+          <a:bodyPr/>
+          <a:lstStyle/>
+          <a:p>
+            <a:r>
+              <a:rPr lang="en-US" dirty="0"/>
+              <a:t>Live Coding: Visualizing Noisy Data</a:t>
+            </a:r>
+          </a:p>
+        </p:txBody>
+      </p:sp>
+      <p:sp>
+        <p:nvSpPr>
+          <p:cNvPr id="3" name="Inhaltsplatzhalter 2">
+            <a:extLst>
+              <a:ext uri="{FF2B5EF4-FFF2-40B4-BE49-F238E27FC236}">
+                <a16:creationId xmlns:a16="http://schemas.microsoft.com/office/drawing/2014/main" id="{F7398BD2-D422-25F5-BFB0-DD9B594C0435}"/>
+              </a:ext>
+            </a:extLst>
+          </p:cNvPr>
+          <p:cNvSpPr>
+            <a:spLocks noGrp="1"/>
+          </p:cNvSpPr>
+          <p:nvPr>
+            <p:ph idx="1"/>
+          </p:nvPr>
+        </p:nvSpPr>
+        <p:spPr/>
+        <p:txBody>
+          <a:bodyPr/>
+          <a:lstStyle/>
+          <a:p>
+            <a:r>
+              <a:rPr lang="en-US" i="1" dirty="0" err="1"/>
+              <a:t>plt.scatter</a:t>
+            </a:r>
+            <a:r>
+              <a:rPr lang="en-US" i="1" dirty="0"/>
+              <a:t>() </a:t>
+            </a:r>
+            <a:r>
+              <a:rPr lang="en-US" dirty="0"/>
+              <a:t>or </a:t>
+            </a:r>
+            <a:r>
+              <a:rPr lang="en-GB" i="1" dirty="0" err="1"/>
+              <a:t>plt.plot</a:t>
+            </a:r>
+            <a:r>
+              <a:rPr lang="en-GB" i="1" dirty="0"/>
+              <a:t>(x, y, marker="x", </a:t>
+            </a:r>
+            <a:r>
+              <a:rPr lang="en-GB" i="1" dirty="0" err="1"/>
+              <a:t>linestyle</a:t>
+            </a:r>
+            <a:r>
+              <a:rPr lang="en-GB" i="1" dirty="0"/>
+              <a:t>="")</a:t>
+            </a:r>
+          </a:p>
+          <a:p>
+            <a:endParaRPr lang="en-US" i="1" dirty="0"/>
+          </a:p>
+        </p:txBody>
+      </p:sp>
+      <p:pic>
+        <p:nvPicPr>
+          <p:cNvPr id="5" name="Grafik 4">
+            <a:extLst>
+              <a:ext uri="{FF2B5EF4-FFF2-40B4-BE49-F238E27FC236}">
+                <a16:creationId xmlns:a16="http://schemas.microsoft.com/office/drawing/2014/main" id="{C101CA24-C238-50B0-DCE2-7D2134797418}"/>
+              </a:ext>
+            </a:extLst>
+          </p:cNvPr>
+          <p:cNvPicPr>
+            <a:picLocks noChangeAspect="1"/>
+          </p:cNvPicPr>
+          <p:nvPr/>
+        </p:nvPicPr>
+        <p:blipFill>
+          <a:blip r:embed="rId2"/>
+          <a:stretch>
+            <a:fillRect/>
+          </a:stretch>
+        </p:blipFill>
+        <p:spPr>
+          <a:xfrm>
+            <a:off x="3030878" y="2585990"/>
+            <a:ext cx="4083356" cy="4171526"/>
+          </a:xfrm>
+          <a:prstGeom prst="rect">
+            <a:avLst/>
+          </a:prstGeom>
+          <a:ln>
+            <a:noFill/>
+          </a:ln>
+          <a:effectLst>
+            <a:outerShdw blurRad="292100" dist="139700" dir="2700000" algn="tl" rotWithShape="0">
+              <a:srgbClr val="333333">
+                <a:alpha val="65000"/>
+              </a:srgbClr>
+            </a:outerShdw>
+          </a:effectLst>
+        </p:spPr>
+      </p:pic>
+    </p:spTree>
+    <p:extLst>
+      <p:ext uri="{BB962C8B-B14F-4D97-AF65-F5344CB8AC3E}">
+        <p14:creationId xmlns:p14="http://schemas.microsoft.com/office/powerpoint/2010/main" val="1924031238"/>
+      </p:ext>
+    </p:extLst>
+  </p:cSld>
+  <p:clrMapOvr>
+    <a:masterClrMapping/>
+  </p:clrMapOvr>
+</p:sld>
+</file>
+
+<file path=ppt/slides/slide4.xml><?xml version="1.0" encoding="utf-8"?>
+<p:sld xmlns:a="http://schemas.openxmlformats.org/drawingml/2006/main" xmlns:r="http://schemas.openxmlformats.org/officeDocument/2006/relationships" xmlns:p="http://schemas.openxmlformats.org/presentationml/2006/main">
+  <p:cSld>
+    <p:spTree>
+      <p:nvGrpSpPr>
+        <p:cNvPr id="1" name=""/>
+        <p:cNvGrpSpPr/>
+        <p:nvPr/>
+      </p:nvGrpSpPr>
+      <p:grpSpPr>
+        <a:xfrm>
+          <a:off x="0" y="0"/>
+          <a:ext cx="0" cy="0"/>
+          <a:chOff x="0" y="0"/>
+          <a:chExt cx="0" cy="0"/>
+        </a:xfrm>
+      </p:grpSpPr>
+      <p:sp>
+        <p:nvSpPr>
+          <p:cNvPr id="2" name="Titel 1">
+            <a:extLst>
+              <a:ext uri="{FF2B5EF4-FFF2-40B4-BE49-F238E27FC236}">
+                <a16:creationId xmlns:a16="http://schemas.microsoft.com/office/drawing/2014/main" id="{71537927-8CAF-B909-7E79-56BB2B379D9C}"/>
+              </a:ext>
+            </a:extLst>
+          </p:cNvPr>
+          <p:cNvSpPr>
+            <a:spLocks noGrp="1"/>
+          </p:cNvSpPr>
+          <p:nvPr>
+            <p:ph type="title"/>
+          </p:nvPr>
+        </p:nvSpPr>
+        <p:spPr/>
+        <p:txBody>
+          <a:bodyPr/>
+          <a:lstStyle/>
+          <a:p>
+            <a:r>
+              <a:rPr lang="en-US" dirty="0" err="1"/>
+              <a:t>Scipy</a:t>
+            </a:r>
+            <a:endParaRPr lang="en-US" dirty="0"/>
+          </a:p>
+        </p:txBody>
+      </p:sp>
+      <p:sp>
+        <p:nvSpPr>
+          <p:cNvPr id="3" name="Inhaltsplatzhalter 2">
+            <a:extLst>
+              <a:ext uri="{FF2B5EF4-FFF2-40B4-BE49-F238E27FC236}">
+                <a16:creationId xmlns:a16="http://schemas.microsoft.com/office/drawing/2014/main" id="{E91A73E8-3EA9-F2D4-AAB9-5891C193DE90}"/>
+              </a:ext>
+            </a:extLst>
+          </p:cNvPr>
+          <p:cNvSpPr>
+            <a:spLocks noGrp="1"/>
+          </p:cNvSpPr>
+          <p:nvPr>
+            <p:ph idx="1"/>
+          </p:nvPr>
+        </p:nvSpPr>
+        <p:spPr/>
+        <p:txBody>
+          <a:bodyPr/>
+          <a:lstStyle/>
+          <a:p>
+            <a:endParaRPr lang="en-US"/>
+          </a:p>
+        </p:txBody>
+      </p:sp>
+    </p:spTree>
+    <p:extLst>
+      <p:ext uri="{BB962C8B-B14F-4D97-AF65-F5344CB8AC3E}">
+        <p14:creationId xmlns:p14="http://schemas.microsoft.com/office/powerpoint/2010/main" val="876603943"/>
+      </p:ext>
+    </p:extLst>
+  </p:cSld>
+  <p:clrMapOvr>
+    <a:masterClrMapping/>
+  </p:clrMapOvr>
+</p:sld>
+</file>
+
+<file path=ppt/slides/slide5.xml><?xml version="1.0" encoding="utf-8"?>
 <p:sld xmlns:a="http://schemas.openxmlformats.org/drawingml/2006/main" xmlns:r="http://schemas.openxmlformats.org/officeDocument/2006/relationships" xmlns:p="http://schemas.openxmlformats.org/presentationml/2006/main">
   <p:cSld>
     <p:spTree>
@@ -4948,7 +5425,7 @@
 </p:sld>
 </file>
 
-<file path=ppt/slides/slide3.xml><?xml version="1.0" encoding="utf-8"?>
+<file path=ppt/slides/slide6.xml><?xml version="1.0" encoding="utf-8"?>
 <p:sld xmlns:a="http://schemas.openxmlformats.org/drawingml/2006/main" xmlns:r="http://schemas.openxmlformats.org/officeDocument/2006/relationships" xmlns:p="http://schemas.openxmlformats.org/presentationml/2006/main">
   <p:cSld>
     <p:spTree>

</xml_diff>

<commit_message>
change live coding files and minor changes chunk 11+12
</commit_message>
<xml_diff>
--- a/Lecture Resources/Lecture Powerpoints/Chunk 12 - Scipy and Linear Regressions.pptx
+++ b/Lecture Resources/Lecture Powerpoints/Chunk 12 - Scipy and Linear Regressions.pptx
@@ -123,7 +123,7 @@
 <file path=ppt/revisionInfo.xml><?xml version="1.0" encoding="utf-8"?>
 <p1510:revInfo xmlns:a="http://schemas.openxmlformats.org/drawingml/2006/main" xmlns:r="http://schemas.openxmlformats.org/officeDocument/2006/relationships" xmlns:p1510="http://schemas.microsoft.com/office/powerpoint/2015/10/main">
   <p1510:revLst>
-    <p1510:client id="{26B21A4E-A3B0-4BFF-AA89-EF6C9284D602}" v="2" dt="2025-10-09T08:45:15.085"/>
+    <p1510:client id="{26B21A4E-A3B0-4BFF-AA89-EF6C9284D602}" v="5" dt="2025-10-09T11:58:07.571"/>
   </p1510:revLst>
 </p1510:revInfo>
 </file>
@@ -219,7 +219,7 @@
   <pc:docChgLst>
     <pc:chgData name="Jonathan Bollig" userId="8b5d0afe-f106-45e0-8c3f-fd98fa124db1" providerId="ADAL" clId="{B2469FA9-EBD8-4834-A16D-CBF8EFC907DD}"/>
     <pc:docChg chg="undo custSel addSld delSld modSld">
-      <pc:chgData name="Jonathan Bollig" userId="8b5d0afe-f106-45e0-8c3f-fd98fa124db1" providerId="ADAL" clId="{B2469FA9-EBD8-4834-A16D-CBF8EFC907DD}" dt="2025-10-09T08:49:10.323" v="276" actId="1440"/>
+      <pc:chgData name="Jonathan Bollig" userId="8b5d0afe-f106-45e0-8c3f-fd98fa124db1" providerId="ADAL" clId="{B2469FA9-EBD8-4834-A16D-CBF8EFC907DD}" dt="2025-10-09T11:58:59.365" v="329" actId="732"/>
       <pc:docMkLst>
         <pc:docMk/>
       </pc:docMkLst>
@@ -281,8 +281,8 @@
           </ac:spMkLst>
         </pc:spChg>
       </pc:sldChg>
-      <pc:sldChg chg="addSp modSp new mod">
-        <pc:chgData name="Jonathan Bollig" userId="8b5d0afe-f106-45e0-8c3f-fd98fa124db1" providerId="ADAL" clId="{B2469FA9-EBD8-4834-A16D-CBF8EFC907DD}" dt="2025-10-09T08:49:10.323" v="276" actId="1440"/>
+      <pc:sldChg chg="addSp delSp modSp new mod modAnim">
+        <pc:chgData name="Jonathan Bollig" userId="8b5d0afe-f106-45e0-8c3f-fd98fa124db1" providerId="ADAL" clId="{B2469FA9-EBD8-4834-A16D-CBF8EFC907DD}" dt="2025-10-09T11:58:59.365" v="329" actId="732"/>
         <pc:sldMkLst>
           <pc:docMk/>
           <pc:sldMk cId="1924031238" sldId="270"/>
@@ -296,19 +296,51 @@
           </ac:spMkLst>
         </pc:spChg>
         <pc:spChg chg="mod">
-          <ac:chgData name="Jonathan Bollig" userId="8b5d0afe-f106-45e0-8c3f-fd98fa124db1" providerId="ADAL" clId="{B2469FA9-EBD8-4834-A16D-CBF8EFC907DD}" dt="2025-10-09T08:37:58.015" v="142" actId="20577"/>
+          <ac:chgData name="Jonathan Bollig" userId="8b5d0afe-f106-45e0-8c3f-fd98fa124db1" providerId="ADAL" clId="{B2469FA9-EBD8-4834-A16D-CBF8EFC907DD}" dt="2025-10-09T11:55:37.436" v="285" actId="20577"/>
           <ac:spMkLst>
             <pc:docMk/>
             <pc:sldMk cId="1924031238" sldId="270"/>
             <ac:spMk id="3" creationId="{F7398BD2-D422-25F5-BFB0-DD9B594C0435}"/>
           </ac:spMkLst>
         </pc:spChg>
-        <pc:picChg chg="add mod">
-          <ac:chgData name="Jonathan Bollig" userId="8b5d0afe-f106-45e0-8c3f-fd98fa124db1" providerId="ADAL" clId="{B2469FA9-EBD8-4834-A16D-CBF8EFC907DD}" dt="2025-10-09T08:49:10.323" v="276" actId="1440"/>
+        <pc:picChg chg="add del mod">
+          <ac:chgData name="Jonathan Bollig" userId="8b5d0afe-f106-45e0-8c3f-fd98fa124db1" providerId="ADAL" clId="{B2469FA9-EBD8-4834-A16D-CBF8EFC907DD}" dt="2025-10-09T11:55:46.908" v="289" actId="478"/>
           <ac:picMkLst>
             <pc:docMk/>
             <pc:sldMk cId="1924031238" sldId="270"/>
             <ac:picMk id="5" creationId="{C101CA24-C238-50B0-DCE2-7D2134797418}"/>
+          </ac:picMkLst>
+        </pc:picChg>
+        <pc:picChg chg="add del mod">
+          <ac:chgData name="Jonathan Bollig" userId="8b5d0afe-f106-45e0-8c3f-fd98fa124db1" providerId="ADAL" clId="{B2469FA9-EBD8-4834-A16D-CBF8EFC907DD}" dt="2025-10-09T11:56:20.225" v="293" actId="478"/>
+          <ac:picMkLst>
+            <pc:docMk/>
+            <pc:sldMk cId="1924031238" sldId="270"/>
+            <ac:picMk id="6" creationId="{3B33E921-C571-AA11-D3A1-251BC5F836B6}"/>
+          </ac:picMkLst>
+        </pc:picChg>
+        <pc:picChg chg="add mod ord">
+          <ac:chgData name="Jonathan Bollig" userId="8b5d0afe-f106-45e0-8c3f-fd98fa124db1" providerId="ADAL" clId="{B2469FA9-EBD8-4834-A16D-CBF8EFC907DD}" dt="2025-10-09T11:58:42.144" v="326" actId="14100"/>
+          <ac:picMkLst>
+            <pc:docMk/>
+            <pc:sldMk cId="1924031238" sldId="270"/>
+            <ac:picMk id="8" creationId="{0BFD0F4B-97F0-1605-0A7C-518F2B29DC65}"/>
+          </ac:picMkLst>
+        </pc:picChg>
+        <pc:picChg chg="add mod">
+          <ac:chgData name="Jonathan Bollig" userId="8b5d0afe-f106-45e0-8c3f-fd98fa124db1" providerId="ADAL" clId="{B2469FA9-EBD8-4834-A16D-CBF8EFC907DD}" dt="2025-10-09T11:58:32.648" v="324" actId="1076"/>
+          <ac:picMkLst>
+            <pc:docMk/>
+            <pc:sldMk cId="1924031238" sldId="270"/>
+            <ac:picMk id="10" creationId="{6B5AA7EE-101A-1097-C726-B548F8F02C8E}"/>
+          </ac:picMkLst>
+        </pc:picChg>
+        <pc:picChg chg="add mod ord modCrop">
+          <ac:chgData name="Jonathan Bollig" userId="8b5d0afe-f106-45e0-8c3f-fd98fa124db1" providerId="ADAL" clId="{B2469FA9-EBD8-4834-A16D-CBF8EFC907DD}" dt="2025-10-09T11:58:59.365" v="329" actId="732"/>
+          <ac:picMkLst>
+            <pc:docMk/>
+            <pc:sldMk cId="1924031238" sldId="270"/>
+            <ac:picMk id="12" creationId="{1792A3AD-2BBB-DEFA-C51A-00889FB295B9}"/>
           </ac:picMkLst>
         </pc:picChg>
       </pc:sldChg>
@@ -592,7 +624,7 @@
           <a:p>
             <a:fld id="{0B6CA2EE-5589-4682-AD7F-744DBF1E81F5}" type="datetimeFigureOut">
               <a:rPr lang="de-DE" smtClean="0"/>
-              <a:t>08.10.2025</a:t>
+              <a:t>09.10.2025</a:t>
             </a:fld>
             <a:endParaRPr lang="de-DE"/>
           </a:p>
@@ -1006,7 +1038,7 @@
           <a:p>
             <a:fld id="{ADA51F25-4808-47F4-BF6E-BCDC230DB01C}" type="datetimeFigureOut">
               <a:rPr lang="de-DE" smtClean="0"/>
-              <a:t>08.10.2025</a:t>
+              <a:t>09.10.2025</a:t>
             </a:fld>
             <a:endParaRPr lang="de-DE"/>
           </a:p>
@@ -1204,7 +1236,7 @@
           <a:p>
             <a:fld id="{ADA51F25-4808-47F4-BF6E-BCDC230DB01C}" type="datetimeFigureOut">
               <a:rPr lang="de-DE" smtClean="0"/>
-              <a:t>08.10.2025</a:t>
+              <a:t>09.10.2025</a:t>
             </a:fld>
             <a:endParaRPr lang="de-DE"/>
           </a:p>
@@ -1412,7 +1444,7 @@
           <a:p>
             <a:fld id="{ADA51F25-4808-47F4-BF6E-BCDC230DB01C}" type="datetimeFigureOut">
               <a:rPr lang="de-DE" smtClean="0"/>
-              <a:t>08.10.2025</a:t>
+              <a:t>09.10.2025</a:t>
             </a:fld>
             <a:endParaRPr lang="de-DE"/>
           </a:p>
@@ -1610,7 +1642,7 @@
           <a:p>
             <a:fld id="{ADA51F25-4808-47F4-BF6E-BCDC230DB01C}" type="datetimeFigureOut">
               <a:rPr lang="de-DE" smtClean="0"/>
-              <a:t>08.10.2025</a:t>
+              <a:t>09.10.2025</a:t>
             </a:fld>
             <a:endParaRPr lang="de-DE"/>
           </a:p>
@@ -1885,7 +1917,7 @@
           <a:p>
             <a:fld id="{ADA51F25-4808-47F4-BF6E-BCDC230DB01C}" type="datetimeFigureOut">
               <a:rPr lang="de-DE" smtClean="0"/>
-              <a:t>08.10.2025</a:t>
+              <a:t>09.10.2025</a:t>
             </a:fld>
             <a:endParaRPr lang="de-DE"/>
           </a:p>
@@ -2150,7 +2182,7 @@
           <a:p>
             <a:fld id="{ADA51F25-4808-47F4-BF6E-BCDC230DB01C}" type="datetimeFigureOut">
               <a:rPr lang="de-DE" smtClean="0"/>
-              <a:t>08.10.2025</a:t>
+              <a:t>09.10.2025</a:t>
             </a:fld>
             <a:endParaRPr lang="de-DE"/>
           </a:p>
@@ -2562,7 +2594,7 @@
           <a:p>
             <a:fld id="{ADA51F25-4808-47F4-BF6E-BCDC230DB01C}" type="datetimeFigureOut">
               <a:rPr lang="de-DE" smtClean="0"/>
-              <a:t>08.10.2025</a:t>
+              <a:t>09.10.2025</a:t>
             </a:fld>
             <a:endParaRPr lang="de-DE"/>
           </a:p>
@@ -2703,7 +2735,7 @@
           <a:p>
             <a:fld id="{ADA51F25-4808-47F4-BF6E-BCDC230DB01C}" type="datetimeFigureOut">
               <a:rPr lang="de-DE" smtClean="0"/>
-              <a:t>08.10.2025</a:t>
+              <a:t>09.10.2025</a:t>
             </a:fld>
             <a:endParaRPr lang="de-DE"/>
           </a:p>
@@ -2816,7 +2848,7 @@
           <a:p>
             <a:fld id="{ADA51F25-4808-47F4-BF6E-BCDC230DB01C}" type="datetimeFigureOut">
               <a:rPr lang="de-DE" smtClean="0"/>
-              <a:t>08.10.2025</a:t>
+              <a:t>09.10.2025</a:t>
             </a:fld>
             <a:endParaRPr lang="de-DE"/>
           </a:p>
@@ -3127,7 +3159,7 @@
           <a:p>
             <a:fld id="{ADA51F25-4808-47F4-BF6E-BCDC230DB01C}" type="datetimeFigureOut">
               <a:rPr lang="de-DE" smtClean="0"/>
-              <a:t>08.10.2025</a:t>
+              <a:t>09.10.2025</a:t>
             </a:fld>
             <a:endParaRPr lang="de-DE"/>
           </a:p>
@@ -3415,7 +3447,7 @@
           <a:p>
             <a:fld id="{ADA51F25-4808-47F4-BF6E-BCDC230DB01C}" type="datetimeFigureOut">
               <a:rPr lang="de-DE" smtClean="0"/>
-              <a:t>08.10.2025</a:t>
+              <a:t>09.10.2025</a:t>
             </a:fld>
             <a:endParaRPr lang="de-DE"/>
           </a:p>
@@ -3656,7 +3688,7 @@
           <a:p>
             <a:fld id="{ADA51F25-4808-47F4-BF6E-BCDC230DB01C}" type="datetimeFigureOut">
               <a:rPr lang="de-DE" smtClean="0"/>
-              <a:t>08.10.2025</a:t>
+              <a:t>09.10.2025</a:t>
             </a:fld>
             <a:endParaRPr lang="de-DE"/>
           </a:p>
@@ -4395,18 +4427,6 @@
           <a:lstStyle/>
           <a:p>
             <a:r>
-              <a:rPr lang="en-US" i="1" dirty="0" err="1"/>
-              <a:t>plt.scatter</a:t>
-            </a:r>
-            <a:r>
-              <a:rPr lang="en-US" i="1" dirty="0"/>
-              <a:t>() </a:t>
-            </a:r>
-            <a:r>
-              <a:rPr lang="en-US" dirty="0"/>
-              <a:t>or </a:t>
-            </a:r>
-            <a:r>
               <a:rPr lang="en-GB" i="1" dirty="0" err="1"/>
               <a:t>plt.plot</a:t>
             </a:r>
@@ -4430,10 +4450,10 @@
       </p:sp>
       <p:pic>
         <p:nvPicPr>
-          <p:cNvPr id="5" name="Grafik 4">
-            <a:extLst>
-              <a:ext uri="{FF2B5EF4-FFF2-40B4-BE49-F238E27FC236}">
-                <a16:creationId xmlns:a16="http://schemas.microsoft.com/office/drawing/2014/main" id="{C101CA24-C238-50B0-DCE2-7D2134797418}"/>
+          <p:cNvPr id="10" name="Grafik 9">
+            <a:extLst>
+              <a:ext uri="{FF2B5EF4-FFF2-40B4-BE49-F238E27FC236}">
+                <a16:creationId xmlns:a16="http://schemas.microsoft.com/office/drawing/2014/main" id="{6B5AA7EE-101A-1097-C726-B548F8F02C8E}"/>
               </a:ext>
             </a:extLst>
           </p:cNvPr>
@@ -4450,8 +4470,89 @@
         </p:blipFill>
         <p:spPr>
           <a:xfrm>
-            <a:off x="3030878" y="2585990"/>
-            <a:ext cx="4083356" cy="4171526"/>
+            <a:off x="3839706" y="2685665"/>
+            <a:ext cx="4648433" cy="3659548"/>
+          </a:xfrm>
+          <a:prstGeom prst="rect">
+            <a:avLst/>
+          </a:prstGeom>
+          <a:ln>
+            <a:noFill/>
+          </a:ln>
+          <a:effectLst>
+            <a:outerShdw blurRad="292100" dist="139700" dir="2700000" algn="tl" rotWithShape="0">
+              <a:srgbClr val="333333">
+                <a:alpha val="65000"/>
+              </a:srgbClr>
+            </a:outerShdw>
+          </a:effectLst>
+        </p:spPr>
+      </p:pic>
+      <p:pic>
+        <p:nvPicPr>
+          <p:cNvPr id="8" name="Grafik 7">
+            <a:extLst>
+              <a:ext uri="{FF2B5EF4-FFF2-40B4-BE49-F238E27FC236}">
+                <a16:creationId xmlns:a16="http://schemas.microsoft.com/office/drawing/2014/main" id="{0BFD0F4B-97F0-1605-0A7C-518F2B29DC65}"/>
+              </a:ext>
+            </a:extLst>
+          </p:cNvPr>
+          <p:cNvPicPr>
+            <a:picLocks noChangeAspect="1"/>
+          </p:cNvPicPr>
+          <p:nvPr/>
+        </p:nvPicPr>
+        <p:blipFill>
+          <a:blip r:embed="rId3"/>
+          <a:stretch>
+            <a:fillRect/>
+          </a:stretch>
+        </p:blipFill>
+        <p:spPr>
+          <a:xfrm>
+            <a:off x="3839706" y="2685665"/>
+            <a:ext cx="4712850" cy="3659548"/>
+          </a:xfrm>
+          <a:prstGeom prst="rect">
+            <a:avLst/>
+          </a:prstGeom>
+          <a:ln>
+            <a:noFill/>
+          </a:ln>
+          <a:effectLst>
+            <a:outerShdw blurRad="292100" dist="139700" dir="2700000" algn="tl" rotWithShape="0">
+              <a:srgbClr val="333333">
+                <a:alpha val="65000"/>
+              </a:srgbClr>
+            </a:outerShdw>
+          </a:effectLst>
+        </p:spPr>
+      </p:pic>
+      <p:pic>
+        <p:nvPicPr>
+          <p:cNvPr id="12" name="Grafik 11">
+            <a:extLst>
+              <a:ext uri="{FF2B5EF4-FFF2-40B4-BE49-F238E27FC236}">
+                <a16:creationId xmlns:a16="http://schemas.microsoft.com/office/drawing/2014/main" id="{1792A3AD-2BBB-DEFA-C51A-00889FB295B9}"/>
+              </a:ext>
+            </a:extLst>
+          </p:cNvPr>
+          <p:cNvPicPr>
+            <a:picLocks noChangeAspect="1"/>
+          </p:cNvPicPr>
+          <p:nvPr/>
+        </p:nvPicPr>
+        <p:blipFill>
+          <a:blip r:embed="rId4"/>
+          <a:srcRect t="20138" r="9772"/>
+          <a:stretch>
+            <a:fillRect/>
+          </a:stretch>
+        </p:blipFill>
+        <p:spPr>
+          <a:xfrm>
+            <a:off x="3811706" y="2685665"/>
+            <a:ext cx="4712850" cy="3659548"/>
           </a:xfrm>
           <a:prstGeom prst="rect">
             <a:avLst/>
@@ -4478,6 +4579,171 @@
   <p:clrMapOvr>
     <a:masterClrMapping/>
   </p:clrMapOvr>
+  <p:timing>
+    <p:tnLst>
+      <p:par>
+        <p:cTn id="1" dur="indefinite" restart="never" nodeType="tmRoot">
+          <p:childTnLst>
+            <p:seq concurrent="1" nextAc="seek">
+              <p:cTn id="2" dur="indefinite" nodeType="mainSeq">
+                <p:childTnLst>
+                  <p:par>
+                    <p:cTn id="3" fill="hold">
+                      <p:stCondLst>
+                        <p:cond delay="indefinite"/>
+                      </p:stCondLst>
+                      <p:childTnLst>
+                        <p:par>
+                          <p:cTn id="4" fill="hold">
+                            <p:stCondLst>
+                              <p:cond delay="0"/>
+                            </p:stCondLst>
+                            <p:childTnLst>
+                              <p:par>
+                                <p:cTn id="5" presetID="1" presetClass="entr" presetSubtype="0" fill="hold" nodeType="clickEffect">
+                                  <p:stCondLst>
+                                    <p:cond delay="0"/>
+                                  </p:stCondLst>
+                                  <p:childTnLst>
+                                    <p:set>
+                                      <p:cBhvr>
+                                        <p:cTn id="6" dur="1" fill="hold">
+                                          <p:stCondLst>
+                                            <p:cond delay="0"/>
+                                          </p:stCondLst>
+                                        </p:cTn>
+                                        <p:tgtEl>
+                                          <p:spTgt spid="10"/>
+                                        </p:tgtEl>
+                                        <p:attrNameLst>
+                                          <p:attrName>style.visibility</p:attrName>
+                                        </p:attrNameLst>
+                                      </p:cBhvr>
+                                      <p:to>
+                                        <p:strVal val="visible"/>
+                                      </p:to>
+                                    </p:set>
+                                  </p:childTnLst>
+                                </p:cTn>
+                              </p:par>
+                            </p:childTnLst>
+                          </p:cTn>
+                        </p:par>
+                      </p:childTnLst>
+                    </p:cTn>
+                  </p:par>
+                  <p:par>
+                    <p:cTn id="7" fill="hold">
+                      <p:stCondLst>
+                        <p:cond delay="indefinite"/>
+                      </p:stCondLst>
+                      <p:childTnLst>
+                        <p:par>
+                          <p:cTn id="8" fill="hold">
+                            <p:stCondLst>
+                              <p:cond delay="0"/>
+                            </p:stCondLst>
+                            <p:childTnLst>
+                              <p:par>
+                                <p:cTn id="9" presetID="1" presetClass="entr" presetSubtype="0" fill="hold" nodeType="clickEffect">
+                                  <p:stCondLst>
+                                    <p:cond delay="0"/>
+                                  </p:stCondLst>
+                                  <p:childTnLst>
+                                    <p:set>
+                                      <p:cBhvr>
+                                        <p:cTn id="10" dur="1" fill="hold">
+                                          <p:stCondLst>
+                                            <p:cond delay="0"/>
+                                          </p:stCondLst>
+                                        </p:cTn>
+                                        <p:tgtEl>
+                                          <p:spTgt spid="8"/>
+                                        </p:tgtEl>
+                                        <p:attrNameLst>
+                                          <p:attrName>style.visibility</p:attrName>
+                                        </p:attrNameLst>
+                                      </p:cBhvr>
+                                      <p:to>
+                                        <p:strVal val="visible"/>
+                                      </p:to>
+                                    </p:set>
+                                  </p:childTnLst>
+                                </p:cTn>
+                              </p:par>
+                            </p:childTnLst>
+                          </p:cTn>
+                        </p:par>
+                      </p:childTnLst>
+                    </p:cTn>
+                  </p:par>
+                  <p:par>
+                    <p:cTn id="11" fill="hold">
+                      <p:stCondLst>
+                        <p:cond delay="indefinite"/>
+                      </p:stCondLst>
+                      <p:childTnLst>
+                        <p:par>
+                          <p:cTn id="12" fill="hold">
+                            <p:stCondLst>
+                              <p:cond delay="0"/>
+                            </p:stCondLst>
+                            <p:childTnLst>
+                              <p:par>
+                                <p:cTn id="13" presetID="1" presetClass="entr" presetSubtype="0" fill="hold" nodeType="clickEffect">
+                                  <p:stCondLst>
+                                    <p:cond delay="0"/>
+                                  </p:stCondLst>
+                                  <p:childTnLst>
+                                    <p:set>
+                                      <p:cBhvr>
+                                        <p:cTn id="14" dur="1" fill="hold">
+                                          <p:stCondLst>
+                                            <p:cond delay="0"/>
+                                          </p:stCondLst>
+                                        </p:cTn>
+                                        <p:tgtEl>
+                                          <p:spTgt spid="12"/>
+                                        </p:tgtEl>
+                                        <p:attrNameLst>
+                                          <p:attrName>style.visibility</p:attrName>
+                                        </p:attrNameLst>
+                                      </p:cBhvr>
+                                      <p:to>
+                                        <p:strVal val="visible"/>
+                                      </p:to>
+                                    </p:set>
+                                  </p:childTnLst>
+                                </p:cTn>
+                              </p:par>
+                            </p:childTnLst>
+                          </p:cTn>
+                        </p:par>
+                      </p:childTnLst>
+                    </p:cTn>
+                  </p:par>
+                </p:childTnLst>
+              </p:cTn>
+              <p:prevCondLst>
+                <p:cond evt="onPrev" delay="0">
+                  <p:tgtEl>
+                    <p:sldTgt/>
+                  </p:tgtEl>
+                </p:cond>
+              </p:prevCondLst>
+              <p:nextCondLst>
+                <p:cond evt="onNext" delay="0">
+                  <p:tgtEl>
+                    <p:sldTgt/>
+                  </p:tgtEl>
+                </p:cond>
+              </p:nextCondLst>
+            </p:seq>
+          </p:childTnLst>
+        </p:cTn>
+      </p:par>
+    </p:tnLst>
+  </p:timing>
 </p:sld>
 </file>
 

</xml_diff>

<commit_message>
All files for chunk 12
</commit_message>
<xml_diff>
--- a/Lecture Resources/Lecture Powerpoints/Chunk 12 - Scipy and Linear Regressions.pptx
+++ b/Lecture Resources/Lecture Powerpoints/Chunk 12 - Scipy and Linear Regressions.pptx
@@ -5,7 +5,7 @@
     <p:sldMasterId id="2147483648" r:id="rId1"/>
   </p:sldMasterIdLst>
   <p:notesMasterIdLst>
-    <p:notesMasterId r:id="rId11"/>
+    <p:notesMasterId r:id="rId10"/>
   </p:notesMasterIdLst>
   <p:sldIdLst>
     <p:sldId id="256" r:id="rId2"/>
@@ -15,8 +15,7 @@
     <p:sldId id="274" r:id="rId6"/>
     <p:sldId id="272" r:id="rId7"/>
     <p:sldId id="275" r:id="rId8"/>
-    <p:sldId id="269" r:id="rId9"/>
-    <p:sldId id="267" r:id="rId10"/>
+    <p:sldId id="267" r:id="rId9"/>
   </p:sldIdLst>
   <p:sldSz cx="12192000" cy="6858000"/>
   <p:notesSz cx="6858000" cy="9144000"/>
@@ -222,7 +221,7 @@
   <pc:docChgLst>
     <pc:chgData name="Jonathan Bollig" userId="8b5d0afe-f106-45e0-8c3f-fd98fa124db1" providerId="ADAL" clId="{B2469FA9-EBD8-4834-A16D-CBF8EFC907DD}"/>
     <pc:docChg chg="undo custSel addSld delSld modSld">
-      <pc:chgData name="Jonathan Bollig" userId="8b5d0afe-f106-45e0-8c3f-fd98fa124db1" providerId="ADAL" clId="{B2469FA9-EBD8-4834-A16D-CBF8EFC907DD}" dt="2025-10-09T18:43:21.088" v="1689" actId="1076"/>
+      <pc:chgData name="Jonathan Bollig" userId="8b5d0afe-f106-45e0-8c3f-fd98fa124db1" providerId="ADAL" clId="{B2469FA9-EBD8-4834-A16D-CBF8EFC907DD}" dt="2025-10-10T08:09:35.100" v="1690" actId="47"/>
       <pc:docMkLst>
         <pc:docMk/>
       </pc:docMkLst>
@@ -333,20 +332,12 @@
           <pc:sldMk cId="2385805343" sldId="268"/>
         </pc:sldMkLst>
       </pc:sldChg>
-      <pc:sldChg chg="modSp add mod">
-        <pc:chgData name="Jonathan Bollig" userId="8b5d0afe-f106-45e0-8c3f-fd98fa124db1" providerId="ADAL" clId="{B2469FA9-EBD8-4834-A16D-CBF8EFC907DD}" dt="2025-10-09T18:27:44.155" v="1348" actId="1076"/>
+      <pc:sldChg chg="modSp add del mod">
+        <pc:chgData name="Jonathan Bollig" userId="8b5d0afe-f106-45e0-8c3f-fd98fa124db1" providerId="ADAL" clId="{B2469FA9-EBD8-4834-A16D-CBF8EFC907DD}" dt="2025-10-10T08:09:35.100" v="1690" actId="47"/>
         <pc:sldMkLst>
           <pc:docMk/>
           <pc:sldMk cId="2113368255" sldId="269"/>
         </pc:sldMkLst>
-        <pc:spChg chg="mod">
-          <ac:chgData name="Jonathan Bollig" userId="8b5d0afe-f106-45e0-8c3f-fd98fa124db1" providerId="ADAL" clId="{B2469FA9-EBD8-4834-A16D-CBF8EFC907DD}" dt="2025-10-04T21:37:04.844" v="18"/>
-          <ac:spMkLst>
-            <pc:docMk/>
-            <pc:sldMk cId="2113368255" sldId="269"/>
-            <ac:spMk id="3" creationId="{90A723FE-AE4A-BC31-F8DA-B479D4E846FF}"/>
-          </ac:spMkLst>
-        </pc:spChg>
         <pc:spChg chg="mod">
           <ac:chgData name="Jonathan Bollig" userId="8b5d0afe-f106-45e0-8c3f-fd98fa124db1" providerId="ADAL" clId="{B2469FA9-EBD8-4834-A16D-CBF8EFC907DD}" dt="2025-10-09T18:27:44.155" v="1348" actId="1076"/>
           <ac:spMkLst>
@@ -720,60 +711,6 @@
 </pc:chgInfo>
 </file>
 
-<file path=ppt/ink/ink1.xml><?xml version="1.0" encoding="utf-8"?>
-<inkml:ink xmlns:inkml="http://www.w3.org/2003/InkML">
-  <inkml:definitions>
-    <inkml:context xml:id="ctx0">
-      <inkml:inkSource xml:id="inkSrc0">
-        <inkml:traceFormat>
-          <inkml:channel name="X" type="integer" min="-2.14748E9" max="2.14748E9" units="cm"/>
-          <inkml:channel name="Y" type="integer" min="-2.14748E9" max="2.14748E9" units="cm"/>
-          <inkml:channel name="F" type="integer" max="32767" units="dev"/>
-        </inkml:traceFormat>
-        <inkml:channelProperties>
-          <inkml:channelProperty channel="X" name="resolution" value="1000" units="1/cm"/>
-          <inkml:channelProperty channel="Y" name="resolution" value="1000" units="1/cm"/>
-          <inkml:channelProperty channel="F" name="resolution" value="0" units="1/dev"/>
-        </inkml:channelProperties>
-      </inkml:inkSource>
-      <inkml:timestamp xml:id="ts0" timeString="2025-10-01T18:39:27.313"/>
-    </inkml:context>
-    <inkml:brush xml:id="br0">
-      <inkml:brushProperty name="width" value="0.035" units="cm"/>
-      <inkml:brushProperty name="height" value="0.035" units="cm"/>
-    </inkml:brush>
-  </inkml:definitions>
-  <inkml:trace contextRef="#ctx0" brushRef="#br0">1 0 24575,'0'7'0,"1"0"0,1-1 0,-1 1 0,1 0 0,0-1 0,0 0 0,1 1 0,0-1 0,4 6 0,35 51 0,32 21 0,-55-65 0,0 1 0,-2 0 0,24 36 0,-41-54 0,1 0 0,0 0 0,1 0 0,-1 0 0,0 0 0,1-1 0,-1 1 0,1 0 0,-1-1 0,1 1 0,0-1 0,-1 1 0,1-1 0,0 0 0,0 0 0,0 0 0,0 0 0,0 0 0,0 0 0,1 0 0,-1-1 0,0 1 0,4-1 0,-1 0 0,0-1 0,0-1 0,-1 1 0,1-1 0,-1 1 0,1-1 0,-1-1 0,0 1 0,1-1 0,5-4 0,96-62 0,-92 64 0,1-1 0,0 2 0,0 0 0,0 0 0,0 2 0,1 0 0,16-1 0,43-6 0,-49 5 0,-19 3 0,-1 1 0,1-1 0,-1 0 0,0-1 0,1 0 0,-1 0 0,0 0 0,0-1 0,11-6 0,-17 9 0,0 0 0,0-1 0,0 1 0,0 0 0,0 0 0,0-1 0,0 1 0,0 0 0,0 0 0,0-1 0,0 1 0,0 0 0,0 0 0,0-1 0,0 1 0,0 0 0,0 0 0,0-1 0,0 1 0,0 0 0,0 0 0,-1-1 0,1 1 0,0 0 0,0 0 0,0 0 0,0-1 0,-1 1 0,1 0 0,0 0 0,0 0 0,0 0 0,-1 0 0,1-1 0,0 1 0,0 0 0,-1 0 0,1 0 0,0 0 0,0 0 0,-1 0 0,1 0 0,0 0 0,0 0 0,-1 0 0,1 0 0,0 0 0,0 0 0,-1 0 0,1 0 0,0 0 0,0 0 0,-1 0 0,1 1 0,-18-4 0,4 3 0,0 0 0,0 1 0,1 0 0,-1 1 0,0 0 0,1 2 0,-1-1 0,1 2 0,0 0 0,0 0 0,-17 11 0,0 3 0,0 1 0,1 2 0,-31 30 0,56-48 0,-1 0 0,1-1 0,-1 0 0,1 0 0,-1 0 0,0 0 0,0-1 0,0 0 0,-1 0 0,1 0 0,0-1 0,-8 2 0,10-3 0,0 0 0,0 0 0,0 0 0,0 0 0,-1-1 0,1 1 0,0-1 0,0 0 0,0 1 0,0-2 0,0 1 0,0 0 0,1 0 0,-1-1 0,0 0 0,1 0 0,-1 1 0,1-1 0,-1-1 0,1 1 0,0 0 0,-4-5 0,-15-20 0,-1 1 0,-1 2 0,-48-40 0,61 55-124,0-1 0,1 0 0,0 0 0,1 0 0,0-2 0,1 1-1,0-1 1,1 1 0,0-2 0,-6-16 0,8 9-6702</inkml:trace>
-</inkml:ink>
-</file>
-
-<file path=ppt/ink/ink2.xml><?xml version="1.0" encoding="utf-8"?>
-<inkml:ink xmlns:inkml="http://www.w3.org/2003/InkML">
-  <inkml:definitions>
-    <inkml:context xml:id="ctx0">
-      <inkml:inkSource xml:id="inkSrc0">
-        <inkml:traceFormat>
-          <inkml:channel name="X" type="integer" min="-2.14748E9" max="2.14748E9" units="cm"/>
-          <inkml:channel name="Y" type="integer" min="-2.14748E9" max="2.14748E9" units="cm"/>
-          <inkml:channel name="F" type="integer" max="32767" units="dev"/>
-        </inkml:traceFormat>
-        <inkml:channelProperties>
-          <inkml:channelProperty channel="X" name="resolution" value="1000" units="1/cm"/>
-          <inkml:channelProperty channel="Y" name="resolution" value="1000" units="1/cm"/>
-          <inkml:channelProperty channel="F" name="resolution" value="0" units="1/dev"/>
-        </inkml:channelProperties>
-      </inkml:inkSource>
-      <inkml:timestamp xml:id="ts0" timeString="2025-10-02T21:25:12.456"/>
-    </inkml:context>
-    <inkml:brush xml:id="br0">
-      <inkml:brushProperty name="width" value="0.035" units="cm"/>
-      <inkml:brushProperty name="height" value="0.035" units="cm"/>
-    </inkml:brush>
-  </inkml:definitions>
-  <inkml:trace contextRef="#ctx0" brushRef="#br0">1 460 24575,'0'-8'0,"1"-1"0,1 2 0,-1-1 0,2 0 0,-1 1 0,0 0 0,1-2 0,0 2 0,5-7 0,38-60 0,35-26 0,-60 78 0,-1-2 0,-1 0 0,26-42 0,-45 64 0,1-1 0,0 1 0,1 0 0,-1-1 0,0 1 0,2 1 0,-2-2 0,1 1 0,-1 1 0,1-1 0,0 0 0,-1 0 0,2 1 0,-1 0 0,0-1 0,0 1 0,0 0 0,0 0 0,1 0 0,0 0 0,-1 1 0,0-2 0,5 2 0,-2 0 0,1 2 0,-1 0 0,0-1 0,0 1 0,-1 0 0,2 0 0,-2 2 0,1-2 0,0 1 0,6 6 0,105 72 0,-101-75 0,2 1 0,-1-2 0,0 0 0,1 0 0,-1-3 0,2 0 0,17 2 0,47 6 0,-54-5 0,-20-4 0,-2-1 0,2 2 0,-2-1 0,1 1 0,1 0 0,-2 1 0,1-1 0,-1 2 0,13 6 0,-19-10 0,0 0 0,0 2 0,0-2 0,0 0 0,0 0 0,0 1 0,0-1 0,0 0 0,0 0 0,0 1 0,0-1 0,0 0 0,0 0 0,0 1 0,0-1 0,0 0 0,0 0 0,0 1 0,0-1 0,0 0 0,0 0 0,-1 2 0,1-2 0,0 0 0,0 0 0,0 0 0,0 1 0,-1-1 0,1 0 0,0 0 0,0 0 0,0 0 0,-1 0 0,1 1 0,0-1 0,0 0 0,-2 0 0,2 0 0,0 0 0,0 0 0,-1 0 0,1 0 0,0 0 0,0 0 0,-1 0 0,1 0 0,0 0 0,0 0 0,-1 0 0,1 0 0,0 0 0,0 0 0,-1 0 0,1-1 0,-20 4 0,5-3 0,0 0 0,0-1 0,0 0 0,0-1 0,0-1 0,1-2 0,-2 2 0,2-3 0,0 0 0,0 0 0,-19-13 0,0-3 0,0-2 0,2-2 0,-35-35 0,62 56 0,-2 0 0,2 2 0,-2-1 0,2 0 0,-2 1 0,1-1 0,0 2 0,-1 0 0,0-1 0,0 1 0,1 1 0,-10-3 0,12 4 0,0 0 0,0 0 0,-1 0 0,1 0 0,-1 1 0,0-1 0,1 2 0,0-1 0,0-1 0,-1 2 0,1-1 0,0 0 0,1 1 0,-2 0 0,1 0 0,1 1 0,-2-2 0,2 1 0,-1 2 0,1-2 0,0 1 0,-5 5 0,-16 24 0,-1-1 0,-1-3 0,-53 48 0,67-66-124,1 2 0,0 0 0,0 0 0,1 0 0,0 2 0,2-1-1,-1 1 1,2-1 0,-1 2 0,-6 20 0,9-12-6702</inkml:trace>
-</inkml:ink>
-</file>
-
 <file path=ppt/notesMasters/notesMaster1.xml><?xml version="1.0" encoding="utf-8"?>
 <p:notesMaster xmlns:a="http://schemas.openxmlformats.org/drawingml/2006/main" xmlns:r="http://schemas.openxmlformats.org/officeDocument/2006/relationships" xmlns:p="http://schemas.openxmlformats.org/presentationml/2006/main">
   <p:cSld>
@@ -856,7 +793,7 @@
           <a:p>
             <a:fld id="{0B6CA2EE-5589-4682-AD7F-744DBF1E81F5}" type="datetimeFigureOut">
               <a:rPr lang="de-DE" smtClean="0"/>
-              <a:t>09.10.2025</a:t>
+              <a:t>10.10.2025</a:t>
             </a:fld>
             <a:endParaRPr lang="de-DE"/>
           </a:p>
@@ -1270,7 +1207,7 @@
           <a:p>
             <a:fld id="{ADA51F25-4808-47F4-BF6E-BCDC230DB01C}" type="datetimeFigureOut">
               <a:rPr lang="de-DE" smtClean="0"/>
-              <a:t>09.10.2025</a:t>
+              <a:t>10.10.2025</a:t>
             </a:fld>
             <a:endParaRPr lang="de-DE"/>
           </a:p>
@@ -1468,7 +1405,7 @@
           <a:p>
             <a:fld id="{ADA51F25-4808-47F4-BF6E-BCDC230DB01C}" type="datetimeFigureOut">
               <a:rPr lang="de-DE" smtClean="0"/>
-              <a:t>09.10.2025</a:t>
+              <a:t>10.10.2025</a:t>
             </a:fld>
             <a:endParaRPr lang="de-DE"/>
           </a:p>
@@ -1676,7 +1613,7 @@
           <a:p>
             <a:fld id="{ADA51F25-4808-47F4-BF6E-BCDC230DB01C}" type="datetimeFigureOut">
               <a:rPr lang="de-DE" smtClean="0"/>
-              <a:t>09.10.2025</a:t>
+              <a:t>10.10.2025</a:t>
             </a:fld>
             <a:endParaRPr lang="de-DE"/>
           </a:p>
@@ -1874,7 +1811,7 @@
           <a:p>
             <a:fld id="{ADA51F25-4808-47F4-BF6E-BCDC230DB01C}" type="datetimeFigureOut">
               <a:rPr lang="de-DE" smtClean="0"/>
-              <a:t>09.10.2025</a:t>
+              <a:t>10.10.2025</a:t>
             </a:fld>
             <a:endParaRPr lang="de-DE"/>
           </a:p>
@@ -2149,7 +2086,7 @@
           <a:p>
             <a:fld id="{ADA51F25-4808-47F4-BF6E-BCDC230DB01C}" type="datetimeFigureOut">
               <a:rPr lang="de-DE" smtClean="0"/>
-              <a:t>09.10.2025</a:t>
+              <a:t>10.10.2025</a:t>
             </a:fld>
             <a:endParaRPr lang="de-DE"/>
           </a:p>
@@ -2414,7 +2351,7 @@
           <a:p>
             <a:fld id="{ADA51F25-4808-47F4-BF6E-BCDC230DB01C}" type="datetimeFigureOut">
               <a:rPr lang="de-DE" smtClean="0"/>
-              <a:t>09.10.2025</a:t>
+              <a:t>10.10.2025</a:t>
             </a:fld>
             <a:endParaRPr lang="de-DE"/>
           </a:p>
@@ -2826,7 +2763,7 @@
           <a:p>
             <a:fld id="{ADA51F25-4808-47F4-BF6E-BCDC230DB01C}" type="datetimeFigureOut">
               <a:rPr lang="de-DE" smtClean="0"/>
-              <a:t>09.10.2025</a:t>
+              <a:t>10.10.2025</a:t>
             </a:fld>
             <a:endParaRPr lang="de-DE"/>
           </a:p>
@@ -2967,7 +2904,7 @@
           <a:p>
             <a:fld id="{ADA51F25-4808-47F4-BF6E-BCDC230DB01C}" type="datetimeFigureOut">
               <a:rPr lang="de-DE" smtClean="0"/>
-              <a:t>09.10.2025</a:t>
+              <a:t>10.10.2025</a:t>
             </a:fld>
             <a:endParaRPr lang="de-DE"/>
           </a:p>
@@ -3080,7 +3017,7 @@
           <a:p>
             <a:fld id="{ADA51F25-4808-47F4-BF6E-BCDC230DB01C}" type="datetimeFigureOut">
               <a:rPr lang="de-DE" smtClean="0"/>
-              <a:t>09.10.2025</a:t>
+              <a:t>10.10.2025</a:t>
             </a:fld>
             <a:endParaRPr lang="de-DE"/>
           </a:p>
@@ -3391,7 +3328,7 @@
           <a:p>
             <a:fld id="{ADA51F25-4808-47F4-BF6E-BCDC230DB01C}" type="datetimeFigureOut">
               <a:rPr lang="de-DE" smtClean="0"/>
-              <a:t>09.10.2025</a:t>
+              <a:t>10.10.2025</a:t>
             </a:fld>
             <a:endParaRPr lang="de-DE"/>
           </a:p>
@@ -3679,7 +3616,7 @@
           <a:p>
             <a:fld id="{ADA51F25-4808-47F4-BF6E-BCDC230DB01C}" type="datetimeFigureOut">
               <a:rPr lang="de-DE" smtClean="0"/>
-              <a:t>09.10.2025</a:t>
+              <a:t>10.10.2025</a:t>
             </a:fld>
             <a:endParaRPr lang="de-DE"/>
           </a:p>
@@ -3920,7 +3857,7 @@
           <a:p>
             <a:fld id="{ADA51F25-4808-47F4-BF6E-BCDC230DB01C}" type="datetimeFigureOut">
               <a:rPr lang="de-DE" smtClean="0"/>
-              <a:t>09.10.2025</a:t>
+              <a:t>10.10.2025</a:t>
             </a:fld>
             <a:endParaRPr lang="de-DE"/>
           </a:p>
@@ -5906,866 +5843,6 @@
 </file>
 
 <file path=ppt/slides/slide8.xml><?xml version="1.0" encoding="utf-8"?>
-<p:sld xmlns:a="http://schemas.openxmlformats.org/drawingml/2006/main" xmlns:r="http://schemas.openxmlformats.org/officeDocument/2006/relationships" xmlns:p="http://schemas.openxmlformats.org/presentationml/2006/main">
-  <p:cSld>
-    <p:spTree>
-      <p:nvGrpSpPr>
-        <p:cNvPr id="1" name=""/>
-        <p:cNvGrpSpPr/>
-        <p:nvPr/>
-      </p:nvGrpSpPr>
-      <p:grpSpPr>
-        <a:xfrm>
-          <a:off x="0" y="0"/>
-          <a:ext cx="0" cy="0"/>
-          <a:chOff x="0" y="0"/>
-          <a:chExt cx="0" cy="0"/>
-        </a:xfrm>
-      </p:grpSpPr>
-      <p:sp>
-        <p:nvSpPr>
-          <p:cNvPr id="2" name="Titel 1">
-            <a:extLst>
-              <a:ext uri="{FF2B5EF4-FFF2-40B4-BE49-F238E27FC236}">
-                <a16:creationId xmlns:a16="http://schemas.microsoft.com/office/drawing/2014/main" id="{6F7A0B5F-607C-4C36-ECF8-BBF9DF9AD9EA}"/>
-              </a:ext>
-            </a:extLst>
-          </p:cNvPr>
-          <p:cNvSpPr>
-            <a:spLocks noGrp="1"/>
-          </p:cNvSpPr>
-          <p:nvPr>
-            <p:ph type="title"/>
-          </p:nvPr>
-        </p:nvSpPr>
-        <p:spPr/>
-        <p:txBody>
-          <a:bodyPr/>
-          <a:lstStyle/>
-          <a:p>
-            <a:r>
-              <a:rPr lang="en-GB" noProof="0" dirty="0"/>
-              <a:t>Sample Slide</a:t>
-            </a:r>
-          </a:p>
-        </p:txBody>
-      </p:sp>
-      <p:sp>
-        <p:nvSpPr>
-          <p:cNvPr id="3" name="Inhaltsplatzhalter 2">
-            <a:extLst>
-              <a:ext uri="{FF2B5EF4-FFF2-40B4-BE49-F238E27FC236}">
-                <a16:creationId xmlns:a16="http://schemas.microsoft.com/office/drawing/2014/main" id="{90A723FE-AE4A-BC31-F8DA-B479D4E846FF}"/>
-              </a:ext>
-            </a:extLst>
-          </p:cNvPr>
-          <p:cNvSpPr>
-            <a:spLocks noGrp="1"/>
-          </p:cNvSpPr>
-          <p:nvPr>
-            <p:ph idx="1"/>
-          </p:nvPr>
-        </p:nvSpPr>
-        <p:spPr/>
-        <p:txBody>
-          <a:bodyPr/>
-          <a:lstStyle/>
-          <a:p>
-            <a:r>
-              <a:rPr lang="en-GB" noProof="0" dirty="0"/>
-              <a:t>Some stuff:</a:t>
-            </a:r>
-            <a:r>
-              <a:rPr lang="de-DE" dirty="0"/>
-              <a:t> ≙ </a:t>
-            </a:r>
-            <a:endParaRPr lang="en-GB" noProof="0" dirty="0"/>
-          </a:p>
-          <a:p>
-            <a:r>
-              <a:rPr lang="en-GB" noProof="0" dirty="0"/>
-              <a:t>Some Emojis 🪄 ⚡</a:t>
-            </a:r>
-            <a:r>
-              <a:rPr lang="en-GB" dirty="0"/>
-              <a:t>🎉</a:t>
-            </a:r>
-            <a:endParaRPr lang="en-GB" noProof="0" dirty="0"/>
-          </a:p>
-        </p:txBody>
-      </p:sp>
-      <p:sp>
-        <p:nvSpPr>
-          <p:cNvPr id="9" name="Textfeld 8">
-            <a:extLst>
-              <a:ext uri="{FF2B5EF4-FFF2-40B4-BE49-F238E27FC236}">
-                <a16:creationId xmlns:a16="http://schemas.microsoft.com/office/drawing/2014/main" id="{0048013B-D3D4-9DD6-10CF-DB86C4AFBFF0}"/>
-              </a:ext>
-            </a:extLst>
-          </p:cNvPr>
-          <p:cNvSpPr txBox="1"/>
-          <p:nvPr/>
-        </p:nvSpPr>
-        <p:spPr>
-          <a:xfrm>
-            <a:off x="8613400" y="4951163"/>
-            <a:ext cx="1149161" cy="276999"/>
-          </a:xfrm>
-          <a:prstGeom prst="rect">
-            <a:avLst/>
-          </a:prstGeom>
-          <a:noFill/>
-        </p:spPr>
-        <p:txBody>
-          <a:bodyPr wrap="none" rtlCol="0">
-            <a:spAutoFit/>
-          </a:bodyPr>
-          <a:lstStyle/>
-          <a:p>
-            <a:r>
-              <a:rPr lang="en-GB" sz="1200" noProof="0" dirty="0">
-                <a:solidFill>
-                  <a:schemeClr val="bg2">
-                    <a:lumMod val="75000"/>
-                  </a:schemeClr>
-                </a:solidFill>
-              </a:rPr>
-              <a:t>[Some source]</a:t>
-            </a:r>
-          </a:p>
-        </p:txBody>
-      </p:sp>
-      <p:cxnSp>
-        <p:nvCxnSpPr>
-          <p:cNvPr id="5" name="Gerade Verbindung mit Pfeil 4">
-            <a:extLst>
-              <a:ext uri="{FF2B5EF4-FFF2-40B4-BE49-F238E27FC236}">
-                <a16:creationId xmlns:a16="http://schemas.microsoft.com/office/drawing/2014/main" id="{D0E19D2E-3C7D-3260-F83F-62D1E1B993E1}"/>
-              </a:ext>
-            </a:extLst>
-          </p:cNvPr>
-          <p:cNvCxnSpPr/>
-          <p:nvPr/>
-        </p:nvCxnSpPr>
-        <p:spPr>
-          <a:xfrm>
-            <a:off x="8505261" y="1246108"/>
-            <a:ext cx="804672" cy="0"/>
-          </a:xfrm>
-          <a:prstGeom prst="straightConnector1">
-            <a:avLst/>
-          </a:prstGeom>
-          <a:ln w="57150" cap="flat" cmpd="sng" algn="ctr">
-            <a:solidFill>
-              <a:schemeClr val="dk1"/>
-            </a:solidFill>
-            <a:prstDash val="solid"/>
-            <a:round/>
-            <a:headEnd type="none" w="med" len="med"/>
-            <a:tailEnd type="arrow" w="med" len="med"/>
-          </a:ln>
-        </p:spPr>
-        <p:style>
-          <a:lnRef idx="0">
-            <a:scrgbClr r="0" g="0" b="0"/>
-          </a:lnRef>
-          <a:fillRef idx="0">
-            <a:scrgbClr r="0" g="0" b="0"/>
-          </a:fillRef>
-          <a:effectRef idx="0">
-            <a:scrgbClr r="0" g="0" b="0"/>
-          </a:effectRef>
-          <a:fontRef idx="minor">
-            <a:schemeClr val="tx1"/>
-          </a:fontRef>
-        </p:style>
-      </p:cxnSp>
-      <p:sp>
-        <p:nvSpPr>
-          <p:cNvPr id="6" name="Rechteck 5">
-            <a:extLst>
-              <a:ext uri="{FF2B5EF4-FFF2-40B4-BE49-F238E27FC236}">
-                <a16:creationId xmlns:a16="http://schemas.microsoft.com/office/drawing/2014/main" id="{5E6DDA9F-0028-564A-CF76-8B73FC5D9E16}"/>
-              </a:ext>
-            </a:extLst>
-          </p:cNvPr>
-          <p:cNvSpPr/>
-          <p:nvPr/>
-        </p:nvSpPr>
-        <p:spPr>
-          <a:xfrm>
-            <a:off x="8438637" y="3139314"/>
-            <a:ext cx="1205052" cy="354019"/>
-          </a:xfrm>
-          <a:prstGeom prst="rect">
-            <a:avLst/>
-          </a:prstGeom>
-          <a:noFill/>
-          <a:ln w="57150" cap="flat" cmpd="sng" algn="ctr">
-            <a:solidFill>
-              <a:srgbClr val="FF0000"/>
-            </a:solidFill>
-            <a:prstDash val="solid"/>
-            <a:round/>
-            <a:headEnd type="none" w="med" len="med"/>
-            <a:tailEnd type="none" w="med" len="med"/>
-          </a:ln>
-        </p:spPr>
-        <p:style>
-          <a:lnRef idx="0">
-            <a:scrgbClr r="0" g="0" b="0"/>
-          </a:lnRef>
-          <a:fillRef idx="0">
-            <a:scrgbClr r="0" g="0" b="0"/>
-          </a:fillRef>
-          <a:effectRef idx="0">
-            <a:scrgbClr r="0" g="0" b="0"/>
-          </a:effectRef>
-          <a:fontRef idx="minor">
-            <a:schemeClr val="accent2"/>
-          </a:fontRef>
-        </p:style>
-        <p:txBody>
-          <a:bodyPr rtlCol="0" anchor="ctr"/>
-          <a:lstStyle/>
-          <a:p>
-            <a:pPr algn="ctr"/>
-            <a:endParaRPr lang="en-GB" noProof="0" dirty="0"/>
-          </a:p>
-        </p:txBody>
-      </p:sp>
-      <p:sp>
-        <p:nvSpPr>
-          <p:cNvPr id="7" name="Rechteck: abgerundete Ecken 6">
-            <a:extLst>
-              <a:ext uri="{FF2B5EF4-FFF2-40B4-BE49-F238E27FC236}">
-                <a16:creationId xmlns:a16="http://schemas.microsoft.com/office/drawing/2014/main" id="{06B693C6-94D4-23F4-7106-30393D062896}"/>
-              </a:ext>
-            </a:extLst>
-          </p:cNvPr>
-          <p:cNvSpPr/>
-          <p:nvPr/>
-        </p:nvSpPr>
-        <p:spPr>
-          <a:xfrm>
-            <a:off x="7717537" y="1730423"/>
-            <a:ext cx="2733427" cy="841248"/>
-          </a:xfrm>
-          <a:prstGeom prst="roundRect">
-            <a:avLst/>
-          </a:prstGeom>
-          <a:solidFill>
-            <a:srgbClr val="FFFFCC"/>
-          </a:solidFill>
-        </p:spPr>
-        <p:style>
-          <a:lnRef idx="2">
-            <a:schemeClr val="accent1">
-              <a:shade val="15000"/>
-            </a:schemeClr>
-          </a:lnRef>
-          <a:fillRef idx="1">
-            <a:schemeClr val="accent1"/>
-          </a:fillRef>
-          <a:effectRef idx="0">
-            <a:schemeClr val="accent1"/>
-          </a:effectRef>
-          <a:fontRef idx="minor">
-            <a:schemeClr val="lt1"/>
-          </a:fontRef>
-        </p:style>
-        <p:txBody>
-          <a:bodyPr rtlCol="0" anchor="ctr"/>
-          <a:lstStyle/>
-          <a:p>
-            <a:pPr algn="ctr"/>
-            <a:r>
-              <a:rPr lang="en-GB" noProof="0" dirty="0">
-                <a:solidFill>
-                  <a:schemeClr val="tx1"/>
-                </a:solidFill>
-              </a:rPr>
-              <a:t>Some Text</a:t>
-            </a:r>
-          </a:p>
-        </p:txBody>
-      </p:sp>
-      <p:sp>
-        <p:nvSpPr>
-          <p:cNvPr id="10" name="Rechteck 9">
-            <a:extLst>
-              <a:ext uri="{FF2B5EF4-FFF2-40B4-BE49-F238E27FC236}">
-                <a16:creationId xmlns:a16="http://schemas.microsoft.com/office/drawing/2014/main" id="{DC754E89-8D5D-89AD-0E54-614A7988FA2D}"/>
-              </a:ext>
-            </a:extLst>
-          </p:cNvPr>
-          <p:cNvSpPr/>
-          <p:nvPr/>
-        </p:nvSpPr>
-        <p:spPr>
-          <a:xfrm>
-            <a:off x="8438638" y="3844747"/>
-            <a:ext cx="1205052" cy="369507"/>
-          </a:xfrm>
-          <a:prstGeom prst="rect">
-            <a:avLst/>
-          </a:prstGeom>
-          <a:noFill/>
-          <a:ln w="57150" cap="flat" cmpd="sng" algn="ctr">
-            <a:solidFill>
-              <a:srgbClr val="FF0000"/>
-            </a:solidFill>
-            <a:prstDash val="sysDot"/>
-            <a:round/>
-            <a:headEnd type="none" w="med" len="med"/>
-            <a:tailEnd type="none" w="med" len="med"/>
-          </a:ln>
-        </p:spPr>
-        <p:style>
-          <a:lnRef idx="0">
-            <a:scrgbClr r="0" g="0" b="0"/>
-          </a:lnRef>
-          <a:fillRef idx="0">
-            <a:scrgbClr r="0" g="0" b="0"/>
-          </a:fillRef>
-          <a:effectRef idx="0">
-            <a:scrgbClr r="0" g="0" b="0"/>
-          </a:effectRef>
-          <a:fontRef idx="minor">
-            <a:schemeClr val="accent2"/>
-          </a:fontRef>
-        </p:style>
-        <p:txBody>
-          <a:bodyPr rtlCol="0" anchor="ctr"/>
-          <a:lstStyle/>
-          <a:p>
-            <a:pPr algn="ctr"/>
-            <a:endParaRPr lang="en-GB" noProof="0" dirty="0"/>
-          </a:p>
-        </p:txBody>
-      </p:sp>
-      <p:sp>
-        <p:nvSpPr>
-          <p:cNvPr id="4" name="Geschweifte Klammer links 3">
-            <a:extLst>
-              <a:ext uri="{FF2B5EF4-FFF2-40B4-BE49-F238E27FC236}">
-                <a16:creationId xmlns:a16="http://schemas.microsoft.com/office/drawing/2014/main" id="{C9816F8C-2CA1-8B84-0DEF-2559334845CB}"/>
-              </a:ext>
-            </a:extLst>
-          </p:cNvPr>
-          <p:cNvSpPr/>
-          <p:nvPr/>
-        </p:nvSpPr>
-        <p:spPr>
-          <a:xfrm>
-            <a:off x="4095750" y="3844747"/>
-            <a:ext cx="371475" cy="1498778"/>
-          </a:xfrm>
-          <a:prstGeom prst="leftBrace">
-            <a:avLst/>
-          </a:prstGeom>
-          <a:ln>
-            <a:solidFill>
-              <a:srgbClr val="FF0000"/>
-            </a:solidFill>
-          </a:ln>
-        </p:spPr>
-        <p:style>
-          <a:lnRef idx="3">
-            <a:schemeClr val="dk1"/>
-          </a:lnRef>
-          <a:fillRef idx="0">
-            <a:schemeClr val="dk1"/>
-          </a:fillRef>
-          <a:effectRef idx="2">
-            <a:schemeClr val="dk1"/>
-          </a:effectRef>
-          <a:fontRef idx="minor">
-            <a:schemeClr val="tx1"/>
-          </a:fontRef>
-        </p:style>
-        <p:txBody>
-          <a:bodyPr rtlCol="0" anchor="ctr"/>
-          <a:lstStyle/>
-          <a:p>
-            <a:pPr algn="ctr"/>
-            <a:endParaRPr lang="de-DE"/>
-          </a:p>
-        </p:txBody>
-      </p:sp>
-      <p:cxnSp>
-        <p:nvCxnSpPr>
-          <p:cNvPr id="11" name="Gerade Verbindung mit Pfeil 10">
-            <a:extLst>
-              <a:ext uri="{FF2B5EF4-FFF2-40B4-BE49-F238E27FC236}">
-                <a16:creationId xmlns:a16="http://schemas.microsoft.com/office/drawing/2014/main" id="{D45E9C49-AF29-868E-5725-AAF5E32A06CD}"/>
-              </a:ext>
-            </a:extLst>
-          </p:cNvPr>
-          <p:cNvCxnSpPr/>
-          <p:nvPr/>
-        </p:nvCxnSpPr>
-        <p:spPr>
-          <a:xfrm>
-            <a:off x="1276350" y="4143375"/>
-            <a:ext cx="1485900" cy="0"/>
-          </a:xfrm>
-          <a:prstGeom prst="straightConnector1">
-            <a:avLst/>
-          </a:prstGeom>
-          <a:ln>
-            <a:solidFill>
-              <a:srgbClr val="FF0000"/>
-            </a:solidFill>
-            <a:tailEnd type="triangle"/>
-          </a:ln>
-        </p:spPr>
-        <p:style>
-          <a:lnRef idx="3">
-            <a:schemeClr val="dk1"/>
-          </a:lnRef>
-          <a:fillRef idx="0">
-            <a:schemeClr val="dk1"/>
-          </a:fillRef>
-          <a:effectRef idx="2">
-            <a:schemeClr val="dk1"/>
-          </a:effectRef>
-          <a:fontRef idx="minor">
-            <a:schemeClr val="tx1"/>
-          </a:fontRef>
-        </p:style>
-      </p:cxnSp>
-      <p:cxnSp>
-        <p:nvCxnSpPr>
-          <p:cNvPr id="12" name="Gerade Verbindung mit Pfeil 11">
-            <a:extLst>
-              <a:ext uri="{FF2B5EF4-FFF2-40B4-BE49-F238E27FC236}">
-                <a16:creationId xmlns:a16="http://schemas.microsoft.com/office/drawing/2014/main" id="{0735E21A-8DAE-07FB-A7AB-EEE014682AED}"/>
-              </a:ext>
-            </a:extLst>
-          </p:cNvPr>
-          <p:cNvCxnSpPr/>
-          <p:nvPr/>
-        </p:nvCxnSpPr>
-        <p:spPr>
-          <a:xfrm>
-            <a:off x="8505261" y="741283"/>
-            <a:ext cx="804672" cy="0"/>
-          </a:xfrm>
-          <a:prstGeom prst="straightConnector1">
-            <a:avLst/>
-          </a:prstGeom>
-          <a:ln w="57150" cap="flat" cmpd="sng" algn="ctr">
-            <a:solidFill>
-              <a:srgbClr val="FF0000"/>
-            </a:solidFill>
-            <a:prstDash val="solid"/>
-            <a:round/>
-            <a:headEnd type="none" w="med" len="med"/>
-            <a:tailEnd type="arrow" w="med" len="med"/>
-          </a:ln>
-        </p:spPr>
-        <p:style>
-          <a:lnRef idx="0">
-            <a:scrgbClr r="0" g="0" b="0"/>
-          </a:lnRef>
-          <a:fillRef idx="0">
-            <a:scrgbClr r="0" g="0" b="0"/>
-          </a:fillRef>
-          <a:effectRef idx="0">
-            <a:scrgbClr r="0" g="0" b="0"/>
-          </a:effectRef>
-          <a:fontRef idx="minor">
-            <a:schemeClr val="tx1"/>
-          </a:fontRef>
-        </p:style>
-      </p:cxnSp>
-      <p:sp>
-        <p:nvSpPr>
-          <p:cNvPr id="13" name="Geschweifte Klammer links 12">
-            <a:extLst>
-              <a:ext uri="{FF2B5EF4-FFF2-40B4-BE49-F238E27FC236}">
-                <a16:creationId xmlns:a16="http://schemas.microsoft.com/office/drawing/2014/main" id="{80C7A375-7DDA-A52D-3BA8-089D75D54106}"/>
-              </a:ext>
-            </a:extLst>
-          </p:cNvPr>
-          <p:cNvSpPr/>
-          <p:nvPr/>
-        </p:nvSpPr>
-        <p:spPr>
-          <a:xfrm>
-            <a:off x="4778783" y="3729384"/>
-            <a:ext cx="371475" cy="1498778"/>
-          </a:xfrm>
-          <a:prstGeom prst="leftBrace">
-            <a:avLst/>
-          </a:prstGeom>
-          <a:ln/>
-        </p:spPr>
-        <p:style>
-          <a:lnRef idx="3">
-            <a:schemeClr val="dk1"/>
-          </a:lnRef>
-          <a:fillRef idx="0">
-            <a:schemeClr val="dk1"/>
-          </a:fillRef>
-          <a:effectRef idx="2">
-            <a:schemeClr val="dk1"/>
-          </a:effectRef>
-          <a:fontRef idx="minor">
-            <a:schemeClr val="tx1"/>
-          </a:fontRef>
-        </p:style>
-        <p:txBody>
-          <a:bodyPr rtlCol="0" anchor="ctr"/>
-          <a:lstStyle/>
-          <a:p>
-            <a:pPr algn="ctr"/>
-            <a:endParaRPr lang="de-DE"/>
-          </a:p>
-        </p:txBody>
-      </p:sp>
-      <p:cxnSp>
-        <p:nvCxnSpPr>
-          <p:cNvPr id="14" name="Gerade Verbindung mit Pfeil 13">
-            <a:extLst>
-              <a:ext uri="{FF2B5EF4-FFF2-40B4-BE49-F238E27FC236}">
-                <a16:creationId xmlns:a16="http://schemas.microsoft.com/office/drawing/2014/main" id="{C702F5FC-9E9D-3E0C-CADB-09F185A8B115}"/>
-              </a:ext>
-            </a:extLst>
-          </p:cNvPr>
-          <p:cNvCxnSpPr/>
-          <p:nvPr/>
-        </p:nvCxnSpPr>
-        <p:spPr>
-          <a:xfrm>
-            <a:off x="1428750" y="4295775"/>
-            <a:ext cx="1485900" cy="0"/>
-          </a:xfrm>
-          <a:prstGeom prst="straightConnector1">
-            <a:avLst/>
-          </a:prstGeom>
-          <a:ln>
-            <a:headEnd type="none" w="med" len="med"/>
-            <a:tailEnd type="arrow" w="med" len="med"/>
-          </a:ln>
-        </p:spPr>
-        <p:style>
-          <a:lnRef idx="3">
-            <a:schemeClr val="dk1"/>
-          </a:lnRef>
-          <a:fillRef idx="0">
-            <a:schemeClr val="dk1"/>
-          </a:fillRef>
-          <a:effectRef idx="2">
-            <a:schemeClr val="dk1"/>
-          </a:effectRef>
-          <a:fontRef idx="minor">
-            <a:schemeClr val="tx1"/>
-          </a:fontRef>
-        </p:style>
-      </p:cxnSp>
-      <p:grpSp>
-        <p:nvGrpSpPr>
-          <p:cNvPr id="8" name="Gruppieren 7">
-            <a:extLst>
-              <a:ext uri="{FF2B5EF4-FFF2-40B4-BE49-F238E27FC236}">
-                <a16:creationId xmlns:a16="http://schemas.microsoft.com/office/drawing/2014/main" id="{B40DEBFD-840B-B742-7AFA-EC30BE390BAA}"/>
-              </a:ext>
-            </a:extLst>
-          </p:cNvPr>
-          <p:cNvGrpSpPr/>
-          <p:nvPr/>
-        </p:nvGrpSpPr>
-        <p:grpSpPr>
-          <a:xfrm>
-            <a:off x="6192077" y="5602008"/>
-            <a:ext cx="2246560" cy="841248"/>
-            <a:chOff x="8440548" y="4177136"/>
-            <a:chExt cx="2246560" cy="841248"/>
-          </a:xfrm>
-        </p:grpSpPr>
-        <p:sp>
-          <p:nvSpPr>
-            <p:cNvPr id="15" name="Bogen 14">
-              <a:extLst>
-                <a:ext uri="{FF2B5EF4-FFF2-40B4-BE49-F238E27FC236}">
-                  <a16:creationId xmlns:a16="http://schemas.microsoft.com/office/drawing/2014/main" id="{8539BDFF-620A-94E9-43C3-7C15B136A22B}"/>
-                </a:ext>
-              </a:extLst>
-            </p:cNvPr>
-            <p:cNvSpPr/>
-            <p:nvPr/>
-          </p:nvSpPr>
-          <p:spPr>
-            <a:xfrm>
-              <a:off x="8531603" y="4177136"/>
-              <a:ext cx="2155505" cy="841248"/>
-            </a:xfrm>
-            <a:prstGeom prst="arc">
-              <a:avLst>
-                <a:gd name="adj1" fmla="val 10743950"/>
-                <a:gd name="adj2" fmla="val 0"/>
-              </a:avLst>
-            </a:prstGeom>
-          </p:spPr>
-          <p:style>
-            <a:lnRef idx="3">
-              <a:schemeClr val="dk1"/>
-            </a:lnRef>
-            <a:fillRef idx="0">
-              <a:schemeClr val="dk1"/>
-            </a:fillRef>
-            <a:effectRef idx="2">
-              <a:schemeClr val="dk1"/>
-            </a:effectRef>
-            <a:fontRef idx="minor">
-              <a:schemeClr val="tx1"/>
-            </a:fontRef>
-          </p:style>
-          <p:txBody>
-            <a:bodyPr rtlCol="0" anchor="ctr"/>
-            <a:lstStyle/>
-            <a:p>
-              <a:pPr algn="ctr"/>
-              <a:endParaRPr lang="de-DE"/>
-            </a:p>
-          </p:txBody>
-        </p:sp>
-        <mc:AlternateContent xmlns:mc="http://schemas.openxmlformats.org/markup-compatibility/2006" xmlns:p14="http://schemas.microsoft.com/office/powerpoint/2010/main">
-          <mc:Choice Requires="p14">
-            <p:contentPart p14:bwMode="auto" r:id="rId2">
-              <p14:nvContentPartPr>
-                <p14:cNvPr id="16" name="Freihand 15">
-                  <a:extLst>
-                    <a:ext uri="{FF2B5EF4-FFF2-40B4-BE49-F238E27FC236}">
-                      <a16:creationId xmlns:a16="http://schemas.microsoft.com/office/drawing/2014/main" id="{85C3B65C-6361-A6C5-6F9A-1B32B4EEBF3B}"/>
-                    </a:ext>
-                  </a:extLst>
-                </p14:cNvPr>
-                <p14:cNvContentPartPr/>
-                <p14:nvPr/>
-              </p14:nvContentPartPr>
-              <p14:xfrm>
-                <a:off x="8440548" y="4481426"/>
-                <a:ext cx="271800" cy="140040"/>
-              </p14:xfrm>
-            </p:contentPart>
-          </mc:Choice>
-          <mc:Fallback xmlns="">
-            <p:pic>
-              <p:nvPicPr>
-                <p:cNvPr id="16" name="Freihand 15">
-                  <a:extLst>
-                    <a:ext uri="{FF2B5EF4-FFF2-40B4-BE49-F238E27FC236}">
-                      <a16:creationId xmlns:a16="http://schemas.microsoft.com/office/drawing/2014/main" id="{85C3B65C-6361-A6C5-6F9A-1B32B4EEBF3B}"/>
-                    </a:ext>
-                  </a:extLst>
-                </p:cNvPr>
-                <p:cNvPicPr/>
-                <p:nvPr/>
-              </p:nvPicPr>
-              <p:blipFill>
-                <a:blip r:embed="rId3"/>
-                <a:stretch>
-                  <a:fillRect/>
-                </a:stretch>
-              </p:blipFill>
-              <p:spPr>
-                <a:xfrm>
-                  <a:off x="8434428" y="4475306"/>
-                  <a:ext cx="284040" cy="152280"/>
-                </a:xfrm>
-                <a:prstGeom prst="rect">
-                  <a:avLst/>
-                </a:prstGeom>
-              </p:spPr>
-            </p:pic>
-          </mc:Fallback>
-        </mc:AlternateContent>
-      </p:grpSp>
-      <p:sp>
-        <p:nvSpPr>
-          <p:cNvPr id="17" name="Rechteck 16">
-            <a:extLst>
-              <a:ext uri="{FF2B5EF4-FFF2-40B4-BE49-F238E27FC236}">
-                <a16:creationId xmlns:a16="http://schemas.microsoft.com/office/drawing/2014/main" id="{72C21F83-4BE3-E6D6-93C2-57E32FFAAD83}"/>
-              </a:ext>
-            </a:extLst>
-          </p:cNvPr>
-          <p:cNvSpPr/>
-          <p:nvPr/>
-        </p:nvSpPr>
-        <p:spPr>
-          <a:xfrm>
-            <a:off x="1542529" y="4642946"/>
-            <a:ext cx="1179576" cy="585216"/>
-          </a:xfrm>
-          <a:prstGeom prst="rect">
-            <a:avLst/>
-          </a:prstGeom>
-          <a:ln w="28575">
-            <a:solidFill>
-              <a:schemeClr val="tx1"/>
-            </a:solidFill>
-          </a:ln>
-        </p:spPr>
-        <p:style>
-          <a:lnRef idx="2">
-            <a:schemeClr val="dk1"/>
-          </a:lnRef>
-          <a:fillRef idx="1">
-            <a:schemeClr val="lt1"/>
-          </a:fillRef>
-          <a:effectRef idx="0">
-            <a:schemeClr val="dk1"/>
-          </a:effectRef>
-          <a:fontRef idx="minor">
-            <a:schemeClr val="dk1"/>
-          </a:fontRef>
-        </p:style>
-        <p:txBody>
-          <a:bodyPr rtlCol="0" anchor="ctr"/>
-          <a:lstStyle/>
-          <a:p>
-            <a:pPr algn="ctr"/>
-            <a:endParaRPr lang="de-DE"/>
-          </a:p>
-        </p:txBody>
-      </p:sp>
-      <p:grpSp>
-        <p:nvGrpSpPr>
-          <p:cNvPr id="18" name="Gruppieren 17">
-            <a:extLst>
-              <a:ext uri="{FF2B5EF4-FFF2-40B4-BE49-F238E27FC236}">
-                <a16:creationId xmlns:a16="http://schemas.microsoft.com/office/drawing/2014/main" id="{7EBD4109-4F5E-85C9-68CB-F0F8BE2E4094}"/>
-              </a:ext>
-            </a:extLst>
-          </p:cNvPr>
-          <p:cNvGrpSpPr/>
-          <p:nvPr/>
-        </p:nvGrpSpPr>
-        <p:grpSpPr>
-          <a:xfrm>
-            <a:off x="3590608" y="5470652"/>
-            <a:ext cx="7363087" cy="841248"/>
-            <a:chOff x="8487235" y="4177136"/>
-            <a:chExt cx="2199873" cy="841248"/>
-          </a:xfrm>
-        </p:grpSpPr>
-        <p:sp>
-          <p:nvSpPr>
-            <p:cNvPr id="19" name="Bogen 18">
-              <a:extLst>
-                <a:ext uri="{FF2B5EF4-FFF2-40B4-BE49-F238E27FC236}">
-                  <a16:creationId xmlns:a16="http://schemas.microsoft.com/office/drawing/2014/main" id="{B2DF59B8-D001-974D-22E2-DC146E9521D9}"/>
-                </a:ext>
-              </a:extLst>
-            </p:cNvPr>
-            <p:cNvSpPr/>
-            <p:nvPr/>
-          </p:nvSpPr>
-          <p:spPr>
-            <a:xfrm>
-              <a:off x="8531603" y="4177136"/>
-              <a:ext cx="2155505" cy="841248"/>
-            </a:xfrm>
-            <a:prstGeom prst="arc">
-              <a:avLst>
-                <a:gd name="adj1" fmla="val 10743950"/>
-                <a:gd name="adj2" fmla="val 0"/>
-              </a:avLst>
-            </a:prstGeom>
-          </p:spPr>
-          <p:style>
-            <a:lnRef idx="3">
-              <a:schemeClr val="dk1"/>
-            </a:lnRef>
-            <a:fillRef idx="0">
-              <a:schemeClr val="dk1"/>
-            </a:fillRef>
-            <a:effectRef idx="2">
-              <a:schemeClr val="dk1"/>
-            </a:effectRef>
-            <a:fontRef idx="minor">
-              <a:schemeClr val="tx1"/>
-            </a:fontRef>
-          </p:style>
-          <p:txBody>
-            <a:bodyPr rtlCol="0" anchor="ctr"/>
-            <a:lstStyle/>
-            <a:p>
-              <a:pPr algn="ctr"/>
-              <a:endParaRPr lang="de-DE"/>
-            </a:p>
-          </p:txBody>
-        </p:sp>
-        <mc:AlternateContent xmlns:mc="http://schemas.openxmlformats.org/markup-compatibility/2006" xmlns:p14="http://schemas.microsoft.com/office/powerpoint/2010/main">
-          <mc:Choice Requires="p14">
-            <p:contentPart p14:bwMode="auto" r:id="rId4">
-              <p14:nvContentPartPr>
-                <p14:cNvPr id="20" name="Freihand 19">
-                  <a:extLst>
-                    <a:ext uri="{FF2B5EF4-FFF2-40B4-BE49-F238E27FC236}">
-                      <a16:creationId xmlns:a16="http://schemas.microsoft.com/office/drawing/2014/main" id="{1147C6B2-FC91-C682-FB16-3DF691E3950B}"/>
-                    </a:ext>
-                  </a:extLst>
-                </p14:cNvPr>
-                <p14:cNvContentPartPr/>
-                <p14:nvPr/>
-              </p14:nvContentPartPr>
-              <p14:xfrm rot="12692638" flipV="1">
-                <a:off x="8487235" y="4476469"/>
-                <a:ext cx="88735" cy="165615"/>
-              </p14:xfrm>
-            </p:contentPart>
-          </mc:Choice>
-          <mc:Fallback xmlns="">
-            <p:pic>
-              <p:nvPicPr>
-                <p:cNvPr id="20" name="Freihand 19">
-                  <a:extLst>
-                    <a:ext uri="{FF2B5EF4-FFF2-40B4-BE49-F238E27FC236}">
-                      <a16:creationId xmlns:a16="http://schemas.microsoft.com/office/drawing/2014/main" id="{1147C6B2-FC91-C682-FB16-3DF691E3950B}"/>
-                    </a:ext>
-                  </a:extLst>
-                </p:cNvPr>
-                <p:cNvPicPr/>
-                <p:nvPr/>
-              </p:nvPicPr>
-              <p:blipFill>
-                <a:blip r:embed="rId5"/>
-                <a:stretch>
-                  <a:fillRect/>
-                </a:stretch>
-              </p:blipFill>
-              <p:spPr>
-                <a:xfrm rot="12692638" flipV="1">
-                  <a:off x="8485404" y="4470348"/>
-                  <a:ext cx="92396" cy="177856"/>
-                </a:xfrm>
-                <a:prstGeom prst="rect">
-                  <a:avLst/>
-                </a:prstGeom>
-              </p:spPr>
-            </p:pic>
-          </mc:Fallback>
-        </mc:AlternateContent>
-      </p:grpSp>
-    </p:spTree>
-    <p:extLst>
-      <p:ext uri="{BB962C8B-B14F-4D97-AF65-F5344CB8AC3E}">
-        <p14:creationId xmlns:p14="http://schemas.microsoft.com/office/powerpoint/2010/main" val="2113368255"/>
-      </p:ext>
-    </p:extLst>
-  </p:cSld>
-  <p:clrMapOvr>
-    <a:masterClrMapping/>
-  </p:clrMapOvr>
-</p:sld>
-</file>
-
-<file path=ppt/slides/slide9.xml><?xml version="1.0" encoding="utf-8"?>
 <p:sld xmlns:a="http://schemas.openxmlformats.org/drawingml/2006/main" xmlns:r="http://schemas.openxmlformats.org/officeDocument/2006/relationships" xmlns:p="http://schemas.openxmlformats.org/presentationml/2006/main">
   <p:cSld>
     <p:spTree>

</xml_diff>

<commit_message>
minor change pptx chunk 12
</commit_message>
<xml_diff>
--- a/Lecture Resources/Lecture Powerpoints/Chunk 12 - Scipy and Linear Regressions.pptx
+++ b/Lecture Resources/Lecture Powerpoints/Chunk 12 - Scipy and Linear Regressions.pptx
@@ -221,22 +221,30 @@
   <pc:docChgLst>
     <pc:chgData name="Jonathan Bollig" userId="8b5d0afe-f106-45e0-8c3f-fd98fa124db1" providerId="ADAL" clId="{B2469FA9-EBD8-4834-A16D-CBF8EFC907DD}"/>
     <pc:docChg chg="undo custSel addSld delSld modSld">
-      <pc:chgData name="Jonathan Bollig" userId="8b5d0afe-f106-45e0-8c3f-fd98fa124db1" providerId="ADAL" clId="{B2469FA9-EBD8-4834-A16D-CBF8EFC907DD}" dt="2025-10-10T08:09:35.100" v="1690" actId="47"/>
+      <pc:chgData name="Jonathan Bollig" userId="8b5d0afe-f106-45e0-8c3f-fd98fa124db1" providerId="ADAL" clId="{B2469FA9-EBD8-4834-A16D-CBF8EFC907DD}" dt="2025-10-10T09:16:59.891" v="1696" actId="14100"/>
       <pc:docMkLst>
         <pc:docMk/>
       </pc:docMkLst>
       <pc:sldChg chg="modSp mod">
-        <pc:chgData name="Jonathan Bollig" userId="8b5d0afe-f106-45e0-8c3f-fd98fa124db1" providerId="ADAL" clId="{B2469FA9-EBD8-4834-A16D-CBF8EFC907DD}" dt="2025-10-08T16:48:27.446" v="71" actId="20577"/>
+        <pc:chgData name="Jonathan Bollig" userId="8b5d0afe-f106-45e0-8c3f-fd98fa124db1" providerId="ADAL" clId="{B2469FA9-EBD8-4834-A16D-CBF8EFC907DD}" dt="2025-10-10T09:16:59.891" v="1696" actId="14100"/>
         <pc:sldMkLst>
           <pc:docMk/>
           <pc:sldMk cId="836289018" sldId="256"/>
         </pc:sldMkLst>
         <pc:spChg chg="mod">
-          <ac:chgData name="Jonathan Bollig" userId="8b5d0afe-f106-45e0-8c3f-fd98fa124db1" providerId="ADAL" clId="{B2469FA9-EBD8-4834-A16D-CBF8EFC907DD}" dt="2025-10-08T16:48:27.446" v="71" actId="20577"/>
+          <ac:chgData name="Jonathan Bollig" userId="8b5d0afe-f106-45e0-8c3f-fd98fa124db1" providerId="ADAL" clId="{B2469FA9-EBD8-4834-A16D-CBF8EFC907DD}" dt="2025-10-10T09:16:59.891" v="1696" actId="14100"/>
           <ac:spMkLst>
             <pc:docMk/>
             <pc:sldMk cId="836289018" sldId="256"/>
             <ac:spMk id="2" creationId="{40F72F59-52B3-6063-A2E3-2AA45125A99B}"/>
+          </ac:spMkLst>
+        </pc:spChg>
+        <pc:spChg chg="mod">
+          <ac:chgData name="Jonathan Bollig" userId="8b5d0afe-f106-45e0-8c3f-fd98fa124db1" providerId="ADAL" clId="{B2469FA9-EBD8-4834-A16D-CBF8EFC907DD}" dt="2025-10-10T09:16:43.847" v="1692" actId="1076"/>
+          <ac:spMkLst>
+            <pc:docMk/>
+            <pc:sldMk cId="836289018" sldId="256"/>
+            <ac:spMk id="3" creationId="{62F76653-44B5-8707-B179-FDB90CB514B7}"/>
           </ac:spMkLst>
         </pc:spChg>
       </pc:sldChg>
@@ -4290,7 +4298,12 @@
             <p:ph type="ctrTitle"/>
           </p:nvPr>
         </p:nvSpPr>
-        <p:spPr/>
+        <p:spPr>
+          <a:xfrm>
+            <a:off x="1145513" y="1725264"/>
+            <a:ext cx="9746900" cy="2387600"/>
+          </a:xfrm>
+        </p:spPr>
         <p:txBody>
           <a:bodyPr>
             <a:normAutofit fontScale="90000"/>
@@ -4309,18 +4322,21 @@
               <a:t>(And everyone else!)</a:t>
             </a:r>
             <a:br>
+              <a:rPr lang="en-US" dirty="0"/>
+            </a:br>
+            <a:br>
               <a:rPr lang="en-US" noProof="0" dirty="0"/>
             </a:br>
             <a:r>
-              <a:rPr lang="en-US" noProof="0" dirty="0"/>
+              <a:rPr lang="en-US" b="1" noProof="0" dirty="0"/>
               <a:t>Chunk 12: </a:t>
             </a:r>
             <a:r>
-              <a:rPr lang="en-US" noProof="0" dirty="0" err="1"/>
+              <a:rPr lang="en-US" b="1" noProof="0" dirty="0" err="1"/>
               <a:t>Scipy</a:t>
             </a:r>
             <a:r>
-              <a:rPr lang="en-US" noProof="0" dirty="0"/>
+              <a:rPr lang="en-US" b="1" noProof="0" dirty="0"/>
               <a:t> &amp; Regressions</a:t>
             </a:r>
           </a:p>
@@ -4342,7 +4358,12 @@
             <p:ph type="subTitle" idx="1"/>
           </p:nvPr>
         </p:nvSpPr>
-        <p:spPr/>
+        <p:spPr>
+          <a:xfrm>
+            <a:off x="1524000" y="4566680"/>
+            <a:ext cx="9144000" cy="1655762"/>
+          </a:xfrm>
+        </p:spPr>
         <p:txBody>
           <a:bodyPr/>
           <a:lstStyle/>

</xml_diff>